<commit_message>
fix: align PowerPoint deck with source contract
</commit_message>
<xml_diff>
--- a/docs/presentations/AI-ChotBot-project-progress-client.pptx
+++ b/docs/presentations/AI-ChotBot-project-progress-client.pptx
@@ -4589,7 +4589,7 @@
             <a:r>
               <a:rPr sz="850" b="0">
                 <a:solidFill>
-                  <a:srgbClr val="FFFFFF"/>
+                  <a:srgbClr val="F4F8FC"/>
                 </a:solidFill>
                 <a:latin typeface="Microsoft JhengHei"/>
               </a:rPr>
@@ -4634,7 +4634,7 @@
             <a:r>
               <a:rPr sz="900" b="1">
                 <a:solidFill>
-                  <a:srgbClr val="FFFFFF"/>
+                  <a:srgbClr val="F4F8FC"/>
                 </a:solidFill>
                 <a:latin typeface="Microsoft JhengHei"/>
               </a:rPr>
@@ -4679,7 +4679,7 @@
             <a:r>
               <a:rPr sz="1100" b="1">
                 <a:solidFill>
-                  <a:srgbClr val="FFFFFF"/>
+                  <a:srgbClr val="F4F8FC"/>
                 </a:solidFill>
                 <a:latin typeface="Microsoft JhengHei"/>
               </a:rPr>
@@ -4724,7 +4724,7 @@
             <a:r>
               <a:rPr sz="3500" b="1">
                 <a:solidFill>
-                  <a:srgbClr val="FFFFFF"/>
+                  <a:srgbClr val="F4F8FC"/>
                 </a:solidFill>
                 <a:latin typeface="Microsoft JhengHei"/>
               </a:rPr>
@@ -4792,7 +4792,7 @@
             <a:r>
               <a:rPr sz="1900" b="1">
                 <a:solidFill>
-                  <a:srgbClr val="FFFFFF"/>
+                  <a:srgbClr val="F4F8FC"/>
                 </a:solidFill>
                 <a:latin typeface="Microsoft JhengHei"/>
               </a:rPr>
@@ -4860,7 +4860,7 @@
             <a:r>
               <a:rPr sz="1500" b="1">
                 <a:solidFill>
-                  <a:srgbClr val="FFFFFF"/>
+                  <a:srgbClr val="F4F8FC"/>
                 </a:solidFill>
                 <a:latin typeface="Microsoft JhengHei"/>
               </a:rPr>
@@ -4928,7 +4928,7 @@
             <a:r>
               <a:rPr sz="1400" b="0">
                 <a:solidFill>
-                  <a:srgbClr val="FFFFFF"/>
+                  <a:srgbClr val="F4F8FC"/>
                 </a:solidFill>
                 <a:latin typeface="Microsoft JhengHei"/>
               </a:rPr>
@@ -4996,7 +4996,7 @@
             <a:r>
               <a:rPr sz="1400" b="0">
                 <a:solidFill>
-                  <a:srgbClr val="FFFFFF"/>
+                  <a:srgbClr val="F4F8FC"/>
                 </a:solidFill>
                 <a:latin typeface="Microsoft JhengHei"/>
               </a:rPr>
@@ -5064,7 +5064,7 @@
             <a:r>
               <a:rPr sz="1400" b="0">
                 <a:solidFill>
-                  <a:srgbClr val="FFFFFF"/>
+                  <a:srgbClr val="F4F8FC"/>
                 </a:solidFill>
                 <a:latin typeface="Microsoft JhengHei"/>
               </a:rPr>
@@ -5132,7 +5132,7 @@
             <a:r>
               <a:rPr sz="1050" b="1">
                 <a:solidFill>
-                  <a:srgbClr val="FFFFFF"/>
+                  <a:srgbClr val="F4F8FC"/>
                 </a:solidFill>
                 <a:latin typeface="Microsoft JhengHei"/>
               </a:rPr>
@@ -5200,7 +5200,7 @@
             <a:r>
               <a:rPr sz="1050" b="1">
                 <a:solidFill>
-                  <a:srgbClr val="FFFFFF"/>
+                  <a:srgbClr val="F4F8FC"/>
                 </a:solidFill>
                 <a:latin typeface="Microsoft JhengHei"/>
               </a:rPr>
@@ -5268,7 +5268,7 @@
             <a:r>
               <a:rPr sz="1050" b="1">
                 <a:solidFill>
-                  <a:srgbClr val="FFFFFF"/>
+                  <a:srgbClr val="F4F8FC"/>
                 </a:solidFill>
                 <a:latin typeface="Microsoft JhengHei"/>
               </a:rPr>
@@ -5382,7 +5382,7 @@
             <a:r>
               <a:rPr sz="850" b="0">
                 <a:solidFill>
-                  <a:srgbClr val="FFFFFF"/>
+                  <a:srgbClr val="F4F8FC"/>
                 </a:solidFill>
                 <a:latin typeface="Microsoft JhengHei"/>
               </a:rPr>
@@ -5427,7 +5427,7 @@
             <a:r>
               <a:rPr sz="900" b="1">
                 <a:solidFill>
-                  <a:srgbClr val="FFFFFF"/>
+                  <a:srgbClr val="F4F8FC"/>
                 </a:solidFill>
                 <a:latin typeface="Microsoft JhengHei"/>
               </a:rPr>
@@ -5472,7 +5472,7 @@
             <a:r>
               <a:rPr sz="950" b="1">
                 <a:solidFill>
-                  <a:srgbClr val="FFFFFF"/>
+                  <a:srgbClr val="F4F8FC"/>
                 </a:solidFill>
                 <a:latin typeface="Microsoft JhengHei"/>
               </a:rPr>
@@ -5517,7 +5517,7 @@
             <a:r>
               <a:rPr sz="2700" b="1">
                 <a:solidFill>
-                  <a:srgbClr val="FFFFFF"/>
+                  <a:srgbClr val="F4F8FC"/>
                 </a:solidFill>
                 <a:latin typeface="Microsoft JhengHei"/>
               </a:rPr>
@@ -5585,7 +5585,7 @@
             <a:r>
               <a:rPr sz="1650" b="1">
                 <a:solidFill>
-                  <a:srgbClr val="FFFFFF"/>
+                  <a:srgbClr val="F4F8FC"/>
                 </a:solidFill>
                 <a:latin typeface="Microsoft JhengHei"/>
               </a:rPr>
@@ -5653,7 +5653,7 @@
             <a:r>
               <a:rPr sz="1600" b="0">
                 <a:solidFill>
-                  <a:srgbClr val="FFFFFF"/>
+                  <a:srgbClr val="F4F8FC"/>
                 </a:solidFill>
                 <a:latin typeface="Microsoft JhengHei"/>
               </a:rPr>
@@ -5717,7 +5717,7 @@
             <a:r>
               <a:rPr sz="950" b="1">
                 <a:solidFill>
-                  <a:srgbClr val="FFFFFF"/>
+                  <a:srgbClr val="F4F8FC"/>
                 </a:solidFill>
                 <a:latin typeface="Microsoft JhengHei"/>
               </a:rPr>
@@ -5785,7 +5785,7 @@
             <a:r>
               <a:rPr sz="1600" b="0">
                 <a:solidFill>
-                  <a:srgbClr val="FFFFFF"/>
+                  <a:srgbClr val="F4F8FC"/>
                 </a:solidFill>
                 <a:latin typeface="Microsoft JhengHei"/>
               </a:rPr>
@@ -5849,7 +5849,7 @@
             <a:r>
               <a:rPr sz="950" b="1">
                 <a:solidFill>
-                  <a:srgbClr val="FFFFFF"/>
+                  <a:srgbClr val="F4F8FC"/>
                 </a:solidFill>
                 <a:latin typeface="Microsoft JhengHei"/>
               </a:rPr>
@@ -5917,7 +5917,7 @@
             <a:r>
               <a:rPr sz="1600" b="0">
                 <a:solidFill>
-                  <a:srgbClr val="FFFFFF"/>
+                  <a:srgbClr val="F4F8FC"/>
                 </a:solidFill>
                 <a:latin typeface="Microsoft JhengHei"/>
               </a:rPr>
@@ -5981,7 +5981,7 @@
             <a:r>
               <a:rPr sz="950" b="1">
                 <a:solidFill>
-                  <a:srgbClr val="FFFFFF"/>
+                  <a:srgbClr val="F4F8FC"/>
                 </a:solidFill>
                 <a:latin typeface="Microsoft JhengHei"/>
               </a:rPr>
@@ -6049,7 +6049,7 @@
             <a:r>
               <a:rPr sz="1600" b="0">
                 <a:solidFill>
-                  <a:srgbClr val="FFFFFF"/>
+                  <a:srgbClr val="F4F8FC"/>
                 </a:solidFill>
                 <a:latin typeface="Microsoft JhengHei"/>
               </a:rPr>
@@ -6113,7 +6113,7 @@
             <a:r>
               <a:rPr sz="950" b="1">
                 <a:solidFill>
-                  <a:srgbClr val="FFFFFF"/>
+                  <a:srgbClr val="F4F8FC"/>
                 </a:solidFill>
                 <a:latin typeface="Microsoft JhengHei"/>
               </a:rPr>
@@ -6181,7 +6181,7 @@
             <a:r>
               <a:rPr sz="1600" b="0">
                 <a:solidFill>
-                  <a:srgbClr val="FFFFFF"/>
+                  <a:srgbClr val="F4F8FC"/>
                 </a:solidFill>
                 <a:latin typeface="Microsoft JhengHei"/>
               </a:rPr>
@@ -6245,7 +6245,7 @@
             <a:r>
               <a:rPr sz="950" b="1">
                 <a:solidFill>
-                  <a:srgbClr val="FFFFFF"/>
+                  <a:srgbClr val="F4F8FC"/>
                 </a:solidFill>
                 <a:latin typeface="Microsoft JhengHei"/>
               </a:rPr>
@@ -6359,7 +6359,7 @@
             <a:r>
               <a:rPr sz="850" b="0">
                 <a:solidFill>
-                  <a:srgbClr val="FFFFFF"/>
+                  <a:srgbClr val="F4F8FC"/>
                 </a:solidFill>
                 <a:latin typeface="Microsoft JhengHei"/>
               </a:rPr>
@@ -6404,7 +6404,7 @@
             <a:r>
               <a:rPr sz="900" b="1">
                 <a:solidFill>
-                  <a:srgbClr val="FFFFFF"/>
+                  <a:srgbClr val="F4F8FC"/>
                 </a:solidFill>
                 <a:latin typeface="Microsoft JhengHei"/>
               </a:rPr>
@@ -6449,7 +6449,7 @@
             <a:r>
               <a:rPr sz="950" b="1">
                 <a:solidFill>
-                  <a:srgbClr val="FFFFFF"/>
+                  <a:srgbClr val="F4F8FC"/>
                 </a:solidFill>
                 <a:latin typeface="Microsoft JhengHei"/>
               </a:rPr>
@@ -6494,7 +6494,7 @@
             <a:r>
               <a:rPr sz="2700" b="1">
                 <a:solidFill>
-                  <a:srgbClr val="FFFFFF"/>
+                  <a:srgbClr val="F4F8FC"/>
                 </a:solidFill>
                 <a:latin typeface="Microsoft JhengHei"/>
               </a:rPr>
@@ -6562,7 +6562,7 @@
             <a:r>
               <a:rPr sz="1650" b="1">
                 <a:solidFill>
-                  <a:srgbClr val="FFFFFF"/>
+                  <a:srgbClr val="F4F8FC"/>
                 </a:solidFill>
                 <a:latin typeface="Microsoft JhengHei"/>
               </a:rPr>
@@ -6630,7 +6630,7 @@
             <a:r>
               <a:rPr sz="1050" b="1">
                 <a:solidFill>
-                  <a:srgbClr val="FFFFFF"/>
+                  <a:srgbClr val="F4F8FC"/>
                 </a:solidFill>
                 <a:latin typeface="Microsoft JhengHei"/>
               </a:rPr>
@@ -6698,7 +6698,7 @@
             <a:r>
               <a:rPr sz="1050" b="1">
                 <a:solidFill>
-                  <a:srgbClr val="FFFFFF"/>
+                  <a:srgbClr val="F4F8FC"/>
                 </a:solidFill>
                 <a:latin typeface="Microsoft JhengHei"/>
               </a:rPr>
@@ -6766,7 +6766,7 @@
             <a:r>
               <a:rPr sz="1050" b="1">
                 <a:solidFill>
-                  <a:srgbClr val="FFFFFF"/>
+                  <a:srgbClr val="F4F8FC"/>
                 </a:solidFill>
                 <a:latin typeface="Microsoft JhengHei"/>
               </a:rPr>
@@ -6834,7 +6834,7 @@
             <a:r>
               <a:rPr sz="1050" b="1">
                 <a:solidFill>
-                  <a:srgbClr val="FFFFFF"/>
+                  <a:srgbClr val="F4F8FC"/>
                 </a:solidFill>
                 <a:latin typeface="Microsoft JhengHei"/>
               </a:rPr>
@@ -6902,7 +6902,7 @@
             <a:r>
               <a:rPr sz="1430" b="0">
                 <a:solidFill>
-                  <a:srgbClr val="FFFFFF"/>
+                  <a:srgbClr val="F4F8FC"/>
                 </a:solidFill>
                 <a:latin typeface="Microsoft JhengHei"/>
               </a:rPr>
@@ -6966,7 +6966,7 @@
             <a:r>
               <a:rPr sz="950" b="1">
                 <a:solidFill>
-                  <a:srgbClr val="FFFFFF"/>
+                  <a:srgbClr val="F4F8FC"/>
                 </a:solidFill>
                 <a:latin typeface="Microsoft JhengHei"/>
               </a:rPr>
@@ -7034,7 +7034,7 @@
             <a:r>
               <a:rPr sz="1430" b="0">
                 <a:solidFill>
-                  <a:srgbClr val="FFFFFF"/>
+                  <a:srgbClr val="F4F8FC"/>
                 </a:solidFill>
                 <a:latin typeface="Microsoft JhengHei"/>
               </a:rPr>
@@ -7098,7 +7098,7 @@
             <a:r>
               <a:rPr sz="950" b="1">
                 <a:solidFill>
-                  <a:srgbClr val="FFFFFF"/>
+                  <a:srgbClr val="F4F8FC"/>
                 </a:solidFill>
                 <a:latin typeface="Microsoft JhengHei"/>
               </a:rPr>
@@ -7166,7 +7166,7 @@
             <a:r>
               <a:rPr sz="1430" b="0">
                 <a:solidFill>
-                  <a:srgbClr val="FFFFFF"/>
+                  <a:srgbClr val="F4F8FC"/>
                 </a:solidFill>
                 <a:latin typeface="Microsoft JhengHei"/>
               </a:rPr>
@@ -7230,7 +7230,7 @@
             <a:r>
               <a:rPr sz="950" b="1">
                 <a:solidFill>
-                  <a:srgbClr val="FFFFFF"/>
+                  <a:srgbClr val="F4F8FC"/>
                 </a:solidFill>
                 <a:latin typeface="Microsoft JhengHei"/>
               </a:rPr>
@@ -7298,7 +7298,7 @@
             <a:r>
               <a:rPr sz="1430" b="0">
                 <a:solidFill>
-                  <a:srgbClr val="FFFFFF"/>
+                  <a:srgbClr val="F4F8FC"/>
                 </a:solidFill>
                 <a:latin typeface="Microsoft JhengHei"/>
               </a:rPr>
@@ -7362,7 +7362,7 @@
             <a:r>
               <a:rPr sz="950" b="1">
                 <a:solidFill>
-                  <a:srgbClr val="FFFFFF"/>
+                  <a:srgbClr val="F4F8FC"/>
                 </a:solidFill>
                 <a:latin typeface="Microsoft JhengHei"/>
               </a:rPr>
@@ -7430,7 +7430,7 @@
             <a:r>
               <a:rPr sz="1430" b="0">
                 <a:solidFill>
-                  <a:srgbClr val="FFFFFF"/>
+                  <a:srgbClr val="F4F8FC"/>
                 </a:solidFill>
                 <a:latin typeface="Microsoft JhengHei"/>
               </a:rPr>
@@ -7494,7 +7494,7 @@
             <a:r>
               <a:rPr sz="950" b="1">
                 <a:solidFill>
-                  <a:srgbClr val="FFFFFF"/>
+                  <a:srgbClr val="F4F8FC"/>
                 </a:solidFill>
                 <a:latin typeface="Microsoft JhengHei"/>
               </a:rPr>
@@ -7608,7 +7608,7 @@
             <a:r>
               <a:rPr sz="850" b="0">
                 <a:solidFill>
-                  <a:srgbClr val="FFFFFF"/>
+                  <a:srgbClr val="F4F8FC"/>
                 </a:solidFill>
                 <a:latin typeface="Microsoft JhengHei"/>
               </a:rPr>
@@ -7653,7 +7653,7 @@
             <a:r>
               <a:rPr sz="900" b="1">
                 <a:solidFill>
-                  <a:srgbClr val="FFFFFF"/>
+                  <a:srgbClr val="F4F8FC"/>
                 </a:solidFill>
                 <a:latin typeface="Microsoft JhengHei"/>
               </a:rPr>
@@ -7698,7 +7698,7 @@
             <a:r>
               <a:rPr sz="950" b="1">
                 <a:solidFill>
-                  <a:srgbClr val="FFFFFF"/>
+                  <a:srgbClr val="F4F8FC"/>
                 </a:solidFill>
                 <a:latin typeface="Microsoft JhengHei"/>
               </a:rPr>
@@ -7743,7 +7743,7 @@
             <a:r>
               <a:rPr sz="2700" b="1">
                 <a:solidFill>
-                  <a:srgbClr val="FFFFFF"/>
+                  <a:srgbClr val="F4F8FC"/>
                 </a:solidFill>
                 <a:latin typeface="Microsoft JhengHei"/>
               </a:rPr>
@@ -7811,7 +7811,7 @@
             <a:r>
               <a:rPr sz="1650" b="1">
                 <a:solidFill>
-                  <a:srgbClr val="FFFFFF"/>
+                  <a:srgbClr val="F4F8FC"/>
                 </a:solidFill>
                 <a:latin typeface="Microsoft JhengHei"/>
               </a:rPr>
@@ -7879,7 +7879,7 @@
             <a:r>
               <a:rPr sz="1050" b="1">
                 <a:solidFill>
-                  <a:srgbClr val="FFFFFF"/>
+                  <a:srgbClr val="F4F8FC"/>
                 </a:solidFill>
                 <a:latin typeface="Microsoft JhengHei"/>
               </a:rPr>
@@ -7947,7 +7947,7 @@
             <a:r>
               <a:rPr sz="1050" b="1">
                 <a:solidFill>
-                  <a:srgbClr val="FFFFFF"/>
+                  <a:srgbClr val="F4F8FC"/>
                 </a:solidFill>
                 <a:latin typeface="Microsoft JhengHei"/>
               </a:rPr>
@@ -8015,7 +8015,7 @@
             <a:r>
               <a:rPr sz="1050" b="1">
                 <a:solidFill>
-                  <a:srgbClr val="FFFFFF"/>
+                  <a:srgbClr val="F4F8FC"/>
                 </a:solidFill>
                 <a:latin typeface="Microsoft JhengHei"/>
               </a:rPr>
@@ -8083,7 +8083,7 @@
             <a:r>
               <a:rPr sz="1050" b="1">
                 <a:solidFill>
-                  <a:srgbClr val="FFFFFF"/>
+                  <a:srgbClr val="F4F8FC"/>
                 </a:solidFill>
                 <a:latin typeface="Microsoft JhengHei"/>
               </a:rPr>
@@ -8151,7 +8151,7 @@
             <a:r>
               <a:rPr sz="1430" b="0">
                 <a:solidFill>
-                  <a:srgbClr val="FFFFFF"/>
+                  <a:srgbClr val="F4F8FC"/>
                 </a:solidFill>
                 <a:latin typeface="Microsoft JhengHei"/>
               </a:rPr>
@@ -8215,7 +8215,7 @@
             <a:r>
               <a:rPr sz="950" b="1">
                 <a:solidFill>
-                  <a:srgbClr val="FFFFFF"/>
+                  <a:srgbClr val="F4F8FC"/>
                 </a:solidFill>
                 <a:latin typeface="Microsoft JhengHei"/>
               </a:rPr>
@@ -8283,7 +8283,7 @@
             <a:r>
               <a:rPr sz="1430" b="0">
                 <a:solidFill>
-                  <a:srgbClr val="FFFFFF"/>
+                  <a:srgbClr val="F4F8FC"/>
                 </a:solidFill>
                 <a:latin typeface="Microsoft JhengHei"/>
               </a:rPr>
@@ -8347,7 +8347,7 @@
             <a:r>
               <a:rPr sz="950" b="1">
                 <a:solidFill>
-                  <a:srgbClr val="FFFFFF"/>
+                  <a:srgbClr val="F4F8FC"/>
                 </a:solidFill>
                 <a:latin typeface="Microsoft JhengHei"/>
               </a:rPr>
@@ -8415,7 +8415,7 @@
             <a:r>
               <a:rPr sz="1430" b="0">
                 <a:solidFill>
-                  <a:srgbClr val="FFFFFF"/>
+                  <a:srgbClr val="F4F8FC"/>
                 </a:solidFill>
                 <a:latin typeface="Microsoft JhengHei"/>
               </a:rPr>
@@ -8479,7 +8479,7 @@
             <a:r>
               <a:rPr sz="950" b="1">
                 <a:solidFill>
-                  <a:srgbClr val="FFFFFF"/>
+                  <a:srgbClr val="F4F8FC"/>
                 </a:solidFill>
                 <a:latin typeface="Microsoft JhengHei"/>
               </a:rPr>
@@ -8547,7 +8547,7 @@
             <a:r>
               <a:rPr sz="1430" b="0">
                 <a:solidFill>
-                  <a:srgbClr val="FFFFFF"/>
+                  <a:srgbClr val="F4F8FC"/>
                 </a:solidFill>
                 <a:latin typeface="Microsoft JhengHei"/>
               </a:rPr>
@@ -8611,7 +8611,7 @@
             <a:r>
               <a:rPr sz="950" b="1">
                 <a:solidFill>
-                  <a:srgbClr val="FFFFFF"/>
+                  <a:srgbClr val="F4F8FC"/>
                 </a:solidFill>
                 <a:latin typeface="Microsoft JhengHei"/>
               </a:rPr>
@@ -8679,7 +8679,7 @@
             <a:r>
               <a:rPr sz="1430" b="0">
                 <a:solidFill>
-                  <a:srgbClr val="FFFFFF"/>
+                  <a:srgbClr val="F4F8FC"/>
                 </a:solidFill>
                 <a:latin typeface="Microsoft JhengHei"/>
               </a:rPr>
@@ -8743,7 +8743,7 @@
             <a:r>
               <a:rPr sz="950" b="1">
                 <a:solidFill>
-                  <a:srgbClr val="FFFFFF"/>
+                  <a:srgbClr val="F4F8FC"/>
                 </a:solidFill>
                 <a:latin typeface="Microsoft JhengHei"/>
               </a:rPr>
@@ -8857,7 +8857,7 @@
             <a:r>
               <a:rPr sz="850" b="0">
                 <a:solidFill>
-                  <a:srgbClr val="FFFFFF"/>
+                  <a:srgbClr val="F4F8FC"/>
                 </a:solidFill>
                 <a:latin typeface="Microsoft JhengHei"/>
               </a:rPr>
@@ -8902,7 +8902,7 @@
             <a:r>
               <a:rPr sz="900" b="1">
                 <a:solidFill>
-                  <a:srgbClr val="FFFFFF"/>
+                  <a:srgbClr val="F4F8FC"/>
                 </a:solidFill>
                 <a:latin typeface="Microsoft JhengHei"/>
               </a:rPr>
@@ -8947,7 +8947,7 @@
             <a:r>
               <a:rPr sz="950" b="1">
                 <a:solidFill>
-                  <a:srgbClr val="FFFFFF"/>
+                  <a:srgbClr val="F4F8FC"/>
                 </a:solidFill>
                 <a:latin typeface="Microsoft JhengHei"/>
               </a:rPr>
@@ -8992,7 +8992,7 @@
             <a:r>
               <a:rPr sz="2700" b="1">
                 <a:solidFill>
-                  <a:srgbClr val="FFFFFF"/>
+                  <a:srgbClr val="F4F8FC"/>
                 </a:solidFill>
                 <a:latin typeface="Microsoft JhengHei"/>
               </a:rPr>
@@ -9060,7 +9060,7 @@
             <a:r>
               <a:rPr sz="1650" b="1">
                 <a:solidFill>
-                  <a:srgbClr val="FFFFFF"/>
+                  <a:srgbClr val="F4F8FC"/>
                 </a:solidFill>
                 <a:latin typeface="Microsoft JhengHei"/>
               </a:rPr>
@@ -9128,7 +9128,7 @@
             <a:r>
               <a:rPr sz="1050" b="1">
                 <a:solidFill>
-                  <a:srgbClr val="FFFFFF"/>
+                  <a:srgbClr val="F4F8FC"/>
                 </a:solidFill>
                 <a:latin typeface="Microsoft JhengHei"/>
               </a:rPr>
@@ -9196,7 +9196,7 @@
             <a:r>
               <a:rPr sz="1050" b="1">
                 <a:solidFill>
-                  <a:srgbClr val="FFFFFF"/>
+                  <a:srgbClr val="F4F8FC"/>
                 </a:solidFill>
                 <a:latin typeface="Microsoft JhengHei"/>
               </a:rPr>
@@ -9264,7 +9264,7 @@
             <a:r>
               <a:rPr sz="1050" b="1">
                 <a:solidFill>
-                  <a:srgbClr val="FFFFFF"/>
+                  <a:srgbClr val="F4F8FC"/>
                 </a:solidFill>
                 <a:latin typeface="Microsoft JhengHei"/>
               </a:rPr>
@@ -9332,7 +9332,7 @@
             <a:r>
               <a:rPr sz="1050" b="1">
                 <a:solidFill>
-                  <a:srgbClr val="FFFFFF"/>
+                  <a:srgbClr val="F4F8FC"/>
                 </a:solidFill>
                 <a:latin typeface="Microsoft JhengHei"/>
               </a:rPr>
@@ -9400,7 +9400,7 @@
             <a:r>
               <a:rPr sz="1430" b="0">
                 <a:solidFill>
-                  <a:srgbClr val="FFFFFF"/>
+                  <a:srgbClr val="F4F8FC"/>
                 </a:solidFill>
                 <a:latin typeface="Microsoft JhengHei"/>
               </a:rPr>
@@ -9464,7 +9464,7 @@
             <a:r>
               <a:rPr sz="950" b="1">
                 <a:solidFill>
-                  <a:srgbClr val="FFFFFF"/>
+                  <a:srgbClr val="F4F8FC"/>
                 </a:solidFill>
                 <a:latin typeface="Microsoft JhengHei"/>
               </a:rPr>
@@ -9532,7 +9532,7 @@
             <a:r>
               <a:rPr sz="1430" b="0">
                 <a:solidFill>
-                  <a:srgbClr val="FFFFFF"/>
+                  <a:srgbClr val="F4F8FC"/>
                 </a:solidFill>
                 <a:latin typeface="Microsoft JhengHei"/>
               </a:rPr>
@@ -9596,7 +9596,7 @@
             <a:r>
               <a:rPr sz="950" b="1">
                 <a:solidFill>
-                  <a:srgbClr val="FFFFFF"/>
+                  <a:srgbClr val="F4F8FC"/>
                 </a:solidFill>
                 <a:latin typeface="Microsoft JhengHei"/>
               </a:rPr>
@@ -9664,7 +9664,7 @@
             <a:r>
               <a:rPr sz="1430" b="0">
                 <a:solidFill>
-                  <a:srgbClr val="FFFFFF"/>
+                  <a:srgbClr val="F4F8FC"/>
                 </a:solidFill>
                 <a:latin typeface="Microsoft JhengHei"/>
               </a:rPr>
@@ -9728,7 +9728,7 @@
             <a:r>
               <a:rPr sz="950" b="1">
                 <a:solidFill>
-                  <a:srgbClr val="FFFFFF"/>
+                  <a:srgbClr val="F4F8FC"/>
                 </a:solidFill>
                 <a:latin typeface="Microsoft JhengHei"/>
               </a:rPr>
@@ -9796,7 +9796,7 @@
             <a:r>
               <a:rPr sz="1430" b="0">
                 <a:solidFill>
-                  <a:srgbClr val="FFFFFF"/>
+                  <a:srgbClr val="F4F8FC"/>
                 </a:solidFill>
                 <a:latin typeface="Microsoft JhengHei"/>
               </a:rPr>
@@ -9860,7 +9860,7 @@
             <a:r>
               <a:rPr sz="950" b="1">
                 <a:solidFill>
-                  <a:srgbClr val="FFFFFF"/>
+                  <a:srgbClr val="F4F8FC"/>
                 </a:solidFill>
                 <a:latin typeface="Microsoft JhengHei"/>
               </a:rPr>
@@ -9928,7 +9928,7 @@
             <a:r>
               <a:rPr sz="1430" b="0">
                 <a:solidFill>
-                  <a:srgbClr val="FFFFFF"/>
+                  <a:srgbClr val="F4F8FC"/>
                 </a:solidFill>
                 <a:latin typeface="Microsoft JhengHei"/>
               </a:rPr>
@@ -9992,7 +9992,7 @@
             <a:r>
               <a:rPr sz="950" b="1">
                 <a:solidFill>
-                  <a:srgbClr val="FFFFFF"/>
+                  <a:srgbClr val="F4F8FC"/>
                 </a:solidFill>
                 <a:latin typeface="Microsoft JhengHei"/>
               </a:rPr>
@@ -10106,7 +10106,7 @@
             <a:r>
               <a:rPr sz="850" b="0">
                 <a:solidFill>
-                  <a:srgbClr val="FFFFFF"/>
+                  <a:srgbClr val="F4F8FC"/>
                 </a:solidFill>
                 <a:latin typeface="Microsoft JhengHei"/>
               </a:rPr>
@@ -10151,7 +10151,7 @@
             <a:r>
               <a:rPr sz="900" b="1">
                 <a:solidFill>
-                  <a:srgbClr val="FFFFFF"/>
+                  <a:srgbClr val="F4F8FC"/>
                 </a:solidFill>
                 <a:latin typeface="Microsoft JhengHei"/>
               </a:rPr>
@@ -10196,7 +10196,7 @@
             <a:r>
               <a:rPr sz="950" b="1">
                 <a:solidFill>
-                  <a:srgbClr val="FFFFFF"/>
+                  <a:srgbClr val="F4F8FC"/>
                 </a:solidFill>
                 <a:latin typeface="Microsoft JhengHei"/>
               </a:rPr>
@@ -10241,7 +10241,7 @@
             <a:r>
               <a:rPr sz="2700" b="1">
                 <a:solidFill>
-                  <a:srgbClr val="FFFFFF"/>
+                  <a:srgbClr val="F4F8FC"/>
                 </a:solidFill>
                 <a:latin typeface="Microsoft JhengHei"/>
               </a:rPr>
@@ -10309,7 +10309,7 @@
             <a:r>
               <a:rPr sz="1650" b="1">
                 <a:solidFill>
-                  <a:srgbClr val="FFFFFF"/>
+                  <a:srgbClr val="F4F8FC"/>
                 </a:solidFill>
                 <a:latin typeface="Microsoft JhengHei"/>
               </a:rPr>
@@ -10687,13 +10687,13 @@
               </a:spcAft>
             </a:pPr>
             <a:r>
-              <a:rPr sz="1300" b="1">
-                <a:solidFill>
-                  <a:srgbClr val="FFFFFF"/>
-                </a:solidFill>
-                <a:latin typeface="Microsoft JhengHei"/>
-              </a:rPr>
-              <a:t>1. 完成分支</a:t>
+              <a:rPr sz="1050" b="1">
+                <a:solidFill>
+                  <a:srgbClr val="F4F8FC"/>
+                </a:solidFill>
+                <a:latin typeface="Microsoft JhengHei"/>
+              </a:rPr>
+              <a:t>1. 完成分支：收斂知識搜尋、清理文件中文亂碼與平行部署副本</a:t>
             </a:r>
           </a:p>
         </p:txBody>
@@ -10755,13 +10755,13 @@
               </a:spcAft>
             </a:pPr>
             <a:r>
-              <a:rPr sz="1300" b="1">
-                <a:solidFill>
-                  <a:srgbClr val="FFFFFF"/>
-                </a:solidFill>
-                <a:latin typeface="Microsoft JhengHei"/>
-              </a:rPr>
-              <a:t>2. 自動化驗證</a:t>
+              <a:rPr sz="1050" b="1">
+                <a:solidFill>
+                  <a:srgbClr val="F4F8FC"/>
+                </a:solidFill>
+                <a:latin typeface="Microsoft JhengHei"/>
+              </a:rPr>
+              <a:t>2. 自動化驗證：修正完整流程測試逾時，更新雲端服務設定的檢查定義後，通過完整測試與上線前自動檢查</a:t>
             </a:r>
           </a:p>
         </p:txBody>
@@ -10823,13 +10823,13 @@
               </a:spcAft>
             </a:pPr>
             <a:r>
-              <a:rPr sz="1300" b="1">
-                <a:solidFill>
-                  <a:srgbClr val="FFFFFF"/>
-                </a:solidFill>
-                <a:latin typeface="Microsoft JhengHei"/>
-              </a:rPr>
-              <a:t>3. 合併</a:t>
+              <a:rPr sz="1050" b="1">
+                <a:solidFill>
+                  <a:srgbClr val="F4F8FC"/>
+                </a:solidFill>
+                <a:latin typeface="Microsoft JhengHei"/>
+              </a:rPr>
+              <a:t>3. 合併：審查後納入正式主線</a:t>
             </a:r>
           </a:p>
         </p:txBody>
@@ -10891,13 +10891,13 @@
               </a:spcAft>
             </a:pPr>
             <a:r>
-              <a:rPr sz="1300" b="1">
-                <a:solidFill>
-                  <a:srgbClr val="FFFFFF"/>
-                </a:solidFill>
-                <a:latin typeface="Microsoft JhengHei"/>
-              </a:rPr>
-              <a:t>4. 正式部署</a:t>
+              <a:rPr sz="1050" b="1">
+                <a:solidFill>
+                  <a:srgbClr val="F4F8FC"/>
+                </a:solidFill>
+                <a:latin typeface="Microsoft JhengHei"/>
+              </a:rPr>
+              <a:t>4. 正式部署：發布設定完整的版本</a:t>
             </a:r>
           </a:p>
         </p:txBody>
@@ -10959,13 +10959,13 @@
               </a:spcAft>
             </a:pPr>
             <a:r>
-              <a:rPr sz="1300" b="1">
-                <a:solidFill>
-                  <a:srgbClr val="FFFFFF"/>
-                </a:solidFill>
-                <a:latin typeface="Microsoft JhengHei"/>
-              </a:rPr>
-              <a:t>5. 實機驗收</a:t>
+              <a:rPr sz="1050" b="1">
+                <a:solidFill>
+                  <a:srgbClr val="F4F8FC"/>
+                </a:solidFill>
+                <a:latin typeface="Microsoft JhengHei"/>
+              </a:rPr>
+              <a:t>5. 實機驗收：用 LINE 完成端到端確認</a:t>
             </a:r>
           </a:p>
         </p:txBody>
@@ -11029,7 +11029,7 @@
             <a:r>
               <a:rPr sz="1250" b="0">
                 <a:solidFill>
-                  <a:srgbClr val="FFFFFF"/>
+                  <a:srgbClr val="F4F8FC"/>
                 </a:solidFill>
                 <a:latin typeface="Microsoft JhengHei"/>
               </a:rPr>
@@ -11093,7 +11093,7 @@
             <a:r>
               <a:rPr sz="950" b="1">
                 <a:solidFill>
-                  <a:srgbClr val="FFFFFF"/>
+                  <a:srgbClr val="F4F8FC"/>
                 </a:solidFill>
                 <a:latin typeface="Microsoft JhengHei"/>
               </a:rPr>
@@ -11161,7 +11161,7 @@
             <a:r>
               <a:rPr sz="1250" b="0">
                 <a:solidFill>
-                  <a:srgbClr val="FFFFFF"/>
+                  <a:srgbClr val="F4F8FC"/>
                 </a:solidFill>
                 <a:latin typeface="Microsoft JhengHei"/>
               </a:rPr>
@@ -11225,7 +11225,7 @@
             <a:r>
               <a:rPr sz="950" b="1">
                 <a:solidFill>
-                  <a:srgbClr val="FFFFFF"/>
+                  <a:srgbClr val="F4F8FC"/>
                 </a:solidFill>
                 <a:latin typeface="Microsoft JhengHei"/>
               </a:rPr>
@@ -11293,7 +11293,7 @@
             <a:r>
               <a:rPr sz="1250" b="0">
                 <a:solidFill>
-                  <a:srgbClr val="FFFFFF"/>
+                  <a:srgbClr val="F4F8FC"/>
                 </a:solidFill>
                 <a:latin typeface="Microsoft JhengHei"/>
               </a:rPr>
@@ -11357,7 +11357,7 @@
             <a:r>
               <a:rPr sz="950" b="1">
                 <a:solidFill>
-                  <a:srgbClr val="FFFFFF"/>
+                  <a:srgbClr val="F4F8FC"/>
                 </a:solidFill>
                 <a:latin typeface="Microsoft JhengHei"/>
               </a:rPr>
@@ -11425,7 +11425,7 @@
             <a:r>
               <a:rPr sz="1250" b="0">
                 <a:solidFill>
-                  <a:srgbClr val="FFFFFF"/>
+                  <a:srgbClr val="F4F8FC"/>
                 </a:solidFill>
                 <a:latin typeface="Microsoft JhengHei"/>
               </a:rPr>
@@ -11489,7 +11489,7 @@
             <a:r>
               <a:rPr sz="950" b="1">
                 <a:solidFill>
-                  <a:srgbClr val="FFFFFF"/>
+                  <a:srgbClr val="F4F8FC"/>
                 </a:solidFill>
                 <a:latin typeface="Microsoft JhengHei"/>
               </a:rPr>
@@ -11557,7 +11557,7 @@
             <a:r>
               <a:rPr sz="1250" b="0">
                 <a:solidFill>
-                  <a:srgbClr val="FFFFFF"/>
+                  <a:srgbClr val="F4F8FC"/>
                 </a:solidFill>
                 <a:latin typeface="Microsoft JhengHei"/>
               </a:rPr>
@@ -11621,7 +11621,7 @@
             <a:r>
               <a:rPr sz="950" b="1">
                 <a:solidFill>
-                  <a:srgbClr val="FFFFFF"/>
+                  <a:srgbClr val="F4F8FC"/>
                 </a:solidFill>
                 <a:latin typeface="Microsoft JhengHei"/>
               </a:rPr>
@@ -11735,7 +11735,7 @@
             <a:r>
               <a:rPr sz="850" b="0">
                 <a:solidFill>
-                  <a:srgbClr val="FFFFFF"/>
+                  <a:srgbClr val="F4F8FC"/>
                 </a:solidFill>
                 <a:latin typeface="Microsoft JhengHei"/>
               </a:rPr>
@@ -11780,7 +11780,7 @@
             <a:r>
               <a:rPr sz="900" b="1">
                 <a:solidFill>
-                  <a:srgbClr val="FFFFFF"/>
+                  <a:srgbClr val="F4F8FC"/>
                 </a:solidFill>
                 <a:latin typeface="Microsoft JhengHei"/>
               </a:rPr>
@@ -11825,7 +11825,7 @@
             <a:r>
               <a:rPr sz="950" b="1">
                 <a:solidFill>
-                  <a:srgbClr val="FFFFFF"/>
+                  <a:srgbClr val="F4F8FC"/>
                 </a:solidFill>
                 <a:latin typeface="Microsoft JhengHei"/>
               </a:rPr>
@@ -11870,7 +11870,7 @@
             <a:r>
               <a:rPr sz="2700" b="1">
                 <a:solidFill>
-                  <a:srgbClr val="FFFFFF"/>
+                  <a:srgbClr val="F4F8FC"/>
                 </a:solidFill>
                 <a:latin typeface="Microsoft JhengHei"/>
               </a:rPr>
@@ -11938,7 +11938,7 @@
             <a:r>
               <a:rPr sz="1650" b="1">
                 <a:solidFill>
-                  <a:srgbClr val="FFFFFF"/>
+                  <a:srgbClr val="F4F8FC"/>
                 </a:solidFill>
                 <a:latin typeface="Microsoft JhengHei"/>
               </a:rPr>
@@ -12006,7 +12006,7 @@
             <a:r>
               <a:rPr sz="1600" b="0">
                 <a:solidFill>
-                  <a:srgbClr val="FFFFFF"/>
+                  <a:srgbClr val="F4F8FC"/>
                 </a:solidFill>
                 <a:latin typeface="Microsoft JhengHei"/>
               </a:rPr>
@@ -12070,7 +12070,7 @@
             <a:r>
               <a:rPr sz="950" b="1">
                 <a:solidFill>
-                  <a:srgbClr val="FFFFFF"/>
+                  <a:srgbClr val="F4F8FC"/>
                 </a:solidFill>
                 <a:latin typeface="Microsoft JhengHei"/>
               </a:rPr>
@@ -12138,7 +12138,7 @@
             <a:r>
               <a:rPr sz="1600" b="0">
                 <a:solidFill>
-                  <a:srgbClr val="FFFFFF"/>
+                  <a:srgbClr val="F4F8FC"/>
                 </a:solidFill>
                 <a:latin typeface="Microsoft JhengHei"/>
               </a:rPr>
@@ -12202,7 +12202,7 @@
             <a:r>
               <a:rPr sz="950" b="1">
                 <a:solidFill>
-                  <a:srgbClr val="FFFFFF"/>
+                  <a:srgbClr val="F4F8FC"/>
                 </a:solidFill>
                 <a:latin typeface="Microsoft JhengHei"/>
               </a:rPr>
@@ -12270,7 +12270,7 @@
             <a:r>
               <a:rPr sz="1600" b="0">
                 <a:solidFill>
-                  <a:srgbClr val="FFFFFF"/>
+                  <a:srgbClr val="F4F8FC"/>
                 </a:solidFill>
                 <a:latin typeface="Microsoft JhengHei"/>
               </a:rPr>
@@ -12334,7 +12334,7 @@
             <a:r>
               <a:rPr sz="950" b="1">
                 <a:solidFill>
-                  <a:srgbClr val="FFFFFF"/>
+                  <a:srgbClr val="F4F8FC"/>
                 </a:solidFill>
                 <a:latin typeface="Microsoft JhengHei"/>
               </a:rPr>
@@ -12402,7 +12402,7 @@
             <a:r>
               <a:rPr sz="1600" b="0">
                 <a:solidFill>
-                  <a:srgbClr val="FFFFFF"/>
+                  <a:srgbClr val="F4F8FC"/>
                 </a:solidFill>
                 <a:latin typeface="Microsoft JhengHei"/>
               </a:rPr>
@@ -12466,7 +12466,7 @@
             <a:r>
               <a:rPr sz="950" b="1">
                 <a:solidFill>
-                  <a:srgbClr val="FFFFFF"/>
+                  <a:srgbClr val="F4F8FC"/>
                 </a:solidFill>
                 <a:latin typeface="Microsoft JhengHei"/>
               </a:rPr>
@@ -12580,7 +12580,7 @@
             <a:r>
               <a:rPr sz="850" b="0">
                 <a:solidFill>
-                  <a:srgbClr val="FFFFFF"/>
+                  <a:srgbClr val="F4F8FC"/>
                 </a:solidFill>
                 <a:latin typeface="Microsoft JhengHei"/>
               </a:rPr>
@@ -12625,7 +12625,7 @@
             <a:r>
               <a:rPr sz="900" b="1">
                 <a:solidFill>
-                  <a:srgbClr val="FFFFFF"/>
+                  <a:srgbClr val="F4F8FC"/>
                 </a:solidFill>
                 <a:latin typeface="Microsoft JhengHei"/>
               </a:rPr>
@@ -12670,7 +12670,7 @@
             <a:r>
               <a:rPr sz="950" b="1">
                 <a:solidFill>
-                  <a:srgbClr val="FFFFFF"/>
+                  <a:srgbClr val="F4F8FC"/>
                 </a:solidFill>
                 <a:latin typeface="Microsoft JhengHei"/>
               </a:rPr>
@@ -12715,7 +12715,7 @@
             <a:r>
               <a:rPr sz="2700" b="1">
                 <a:solidFill>
-                  <a:srgbClr val="FFFFFF"/>
+                  <a:srgbClr val="F4F8FC"/>
                 </a:solidFill>
                 <a:latin typeface="Microsoft JhengHei"/>
               </a:rPr>
@@ -12783,7 +12783,7 @@
             <a:r>
               <a:rPr sz="1650" b="1">
                 <a:solidFill>
-                  <a:srgbClr val="FFFFFF"/>
+                  <a:srgbClr val="F4F8FC"/>
                 </a:solidFill>
                 <a:latin typeface="Microsoft JhengHei"/>
               </a:rPr>
@@ -12851,7 +12851,7 @@
             <a:r>
               <a:rPr sz="1600" b="0">
                 <a:solidFill>
-                  <a:srgbClr val="FFFFFF"/>
+                  <a:srgbClr val="F4F8FC"/>
                 </a:solidFill>
                 <a:latin typeface="Microsoft JhengHei"/>
               </a:rPr>
@@ -12915,7 +12915,7 @@
             <a:r>
               <a:rPr sz="950" b="1">
                 <a:solidFill>
-                  <a:srgbClr val="FFFFFF"/>
+                  <a:srgbClr val="F4F8FC"/>
                 </a:solidFill>
                 <a:latin typeface="Microsoft JhengHei"/>
               </a:rPr>
@@ -12983,7 +12983,7 @@
             <a:r>
               <a:rPr sz="1600" b="0">
                 <a:solidFill>
-                  <a:srgbClr val="FFFFFF"/>
+                  <a:srgbClr val="F4F8FC"/>
                 </a:solidFill>
                 <a:latin typeface="Microsoft JhengHei"/>
               </a:rPr>
@@ -13047,7 +13047,7 @@
             <a:r>
               <a:rPr sz="950" b="1">
                 <a:solidFill>
-                  <a:srgbClr val="FFFFFF"/>
+                  <a:srgbClr val="F4F8FC"/>
                 </a:solidFill>
                 <a:latin typeface="Microsoft JhengHei"/>
               </a:rPr>
@@ -13115,7 +13115,7 @@
             <a:r>
               <a:rPr sz="1600" b="0">
                 <a:solidFill>
-                  <a:srgbClr val="FFFFFF"/>
+                  <a:srgbClr val="F4F8FC"/>
                 </a:solidFill>
                 <a:latin typeface="Microsoft JhengHei"/>
               </a:rPr>
@@ -13179,7 +13179,7 @@
             <a:r>
               <a:rPr sz="950" b="1">
                 <a:solidFill>
-                  <a:srgbClr val="FFFFFF"/>
+                  <a:srgbClr val="F4F8FC"/>
                 </a:solidFill>
                 <a:latin typeface="Microsoft JhengHei"/>
               </a:rPr>
@@ -13247,7 +13247,7 @@
             <a:r>
               <a:rPr sz="1600" b="0">
                 <a:solidFill>
-                  <a:srgbClr val="FFFFFF"/>
+                  <a:srgbClr val="F4F8FC"/>
                 </a:solidFill>
                 <a:latin typeface="Microsoft JhengHei"/>
               </a:rPr>
@@ -13311,7 +13311,7 @@
             <a:r>
               <a:rPr sz="950" b="1">
                 <a:solidFill>
-                  <a:srgbClr val="FFFFFF"/>
+                  <a:srgbClr val="F4F8FC"/>
                 </a:solidFill>
                 <a:latin typeface="Microsoft JhengHei"/>
               </a:rPr>
@@ -13425,7 +13425,7 @@
             <a:r>
               <a:rPr sz="850" b="0">
                 <a:solidFill>
-                  <a:srgbClr val="FFFFFF"/>
+                  <a:srgbClr val="F4F8FC"/>
                 </a:solidFill>
                 <a:latin typeface="Microsoft JhengHei"/>
               </a:rPr>
@@ -13470,7 +13470,7 @@
             <a:r>
               <a:rPr sz="900" b="1">
                 <a:solidFill>
-                  <a:srgbClr val="FFFFFF"/>
+                  <a:srgbClr val="F4F8FC"/>
                 </a:solidFill>
                 <a:latin typeface="Microsoft JhengHei"/>
               </a:rPr>
@@ -13515,7 +13515,7 @@
             <a:r>
               <a:rPr sz="950" b="1">
                 <a:solidFill>
-                  <a:srgbClr val="FFFFFF"/>
+                  <a:srgbClr val="F4F8FC"/>
                 </a:solidFill>
                 <a:latin typeface="Microsoft JhengHei"/>
               </a:rPr>
@@ -13560,7 +13560,7 @@
             <a:r>
               <a:rPr sz="2700" b="1">
                 <a:solidFill>
-                  <a:srgbClr val="FFFFFF"/>
+                  <a:srgbClr val="F4F8FC"/>
                 </a:solidFill>
                 <a:latin typeface="Microsoft JhengHei"/>
               </a:rPr>
@@ -13628,7 +13628,7 @@
             <a:r>
               <a:rPr sz="1650" b="1">
                 <a:solidFill>
-                  <a:srgbClr val="FFFFFF"/>
+                  <a:srgbClr val="F4F8FC"/>
                 </a:solidFill>
                 <a:latin typeface="Microsoft JhengHei"/>
               </a:rPr>
@@ -13696,7 +13696,7 @@
             <a:r>
               <a:rPr sz="1600" b="0">
                 <a:solidFill>
-                  <a:srgbClr val="FFFFFF"/>
+                  <a:srgbClr val="F4F8FC"/>
                 </a:solidFill>
                 <a:latin typeface="Microsoft JhengHei"/>
               </a:rPr>
@@ -13760,7 +13760,7 @@
             <a:r>
               <a:rPr sz="950" b="1">
                 <a:solidFill>
-                  <a:srgbClr val="FFFFFF"/>
+                  <a:srgbClr val="F4F8FC"/>
                 </a:solidFill>
                 <a:latin typeface="Microsoft JhengHei"/>
               </a:rPr>
@@ -13828,7 +13828,7 @@
             <a:r>
               <a:rPr sz="1600" b="0">
                 <a:solidFill>
-                  <a:srgbClr val="FFFFFF"/>
+                  <a:srgbClr val="F4F8FC"/>
                 </a:solidFill>
                 <a:latin typeface="Microsoft JhengHei"/>
               </a:rPr>
@@ -13892,7 +13892,7 @@
             <a:r>
               <a:rPr sz="950" b="1">
                 <a:solidFill>
-                  <a:srgbClr val="FFFFFF"/>
+                  <a:srgbClr val="F4F8FC"/>
                 </a:solidFill>
                 <a:latin typeface="Microsoft JhengHei"/>
               </a:rPr>
@@ -13960,7 +13960,7 @@
             <a:r>
               <a:rPr sz="1600" b="0">
                 <a:solidFill>
-                  <a:srgbClr val="FFFFFF"/>
+                  <a:srgbClr val="F4F8FC"/>
                 </a:solidFill>
                 <a:latin typeface="Microsoft JhengHei"/>
               </a:rPr>
@@ -14024,7 +14024,7 @@
             <a:r>
               <a:rPr sz="950" b="1">
                 <a:solidFill>
-                  <a:srgbClr val="FFFFFF"/>
+                  <a:srgbClr val="F4F8FC"/>
                 </a:solidFill>
                 <a:latin typeface="Microsoft JhengHei"/>
               </a:rPr>
@@ -14092,7 +14092,7 @@
             <a:r>
               <a:rPr sz="1600" b="0">
                 <a:solidFill>
-                  <a:srgbClr val="FFFFFF"/>
+                  <a:srgbClr val="F4F8FC"/>
                 </a:solidFill>
                 <a:latin typeface="Microsoft JhengHei"/>
               </a:rPr>
@@ -14156,7 +14156,7 @@
             <a:r>
               <a:rPr sz="950" b="1">
                 <a:solidFill>
-                  <a:srgbClr val="FFFFFF"/>
+                  <a:srgbClr val="F4F8FC"/>
                 </a:solidFill>
                 <a:latin typeface="Microsoft JhengHei"/>
               </a:rPr>
@@ -14224,7 +14224,7 @@
             <a:r>
               <a:rPr sz="1600" b="0">
                 <a:solidFill>
-                  <a:srgbClr val="FFFFFF"/>
+                  <a:srgbClr val="F4F8FC"/>
                 </a:solidFill>
                 <a:latin typeface="Microsoft JhengHei"/>
               </a:rPr>
@@ -14288,7 +14288,7 @@
             <a:r>
               <a:rPr sz="950" b="1">
                 <a:solidFill>
-                  <a:srgbClr val="FFFFFF"/>
+                  <a:srgbClr val="F4F8FC"/>
                 </a:solidFill>
                 <a:latin typeface="Microsoft JhengHei"/>
               </a:rPr>
@@ -14402,7 +14402,7 @@
             <a:r>
               <a:rPr sz="850" b="0">
                 <a:solidFill>
-                  <a:srgbClr val="FFFFFF"/>
+                  <a:srgbClr val="F4F8FC"/>
                 </a:solidFill>
                 <a:latin typeface="Microsoft JhengHei"/>
               </a:rPr>
@@ -14447,7 +14447,7 @@
             <a:r>
               <a:rPr sz="900" b="1">
                 <a:solidFill>
-                  <a:srgbClr val="FFFFFF"/>
+                  <a:srgbClr val="F4F8FC"/>
                 </a:solidFill>
                 <a:latin typeface="Microsoft JhengHei"/>
               </a:rPr>
@@ -14492,7 +14492,7 @@
             <a:r>
               <a:rPr sz="950" b="1">
                 <a:solidFill>
-                  <a:srgbClr val="FFFFFF"/>
+                  <a:srgbClr val="F4F8FC"/>
                 </a:solidFill>
                 <a:latin typeface="Microsoft JhengHei"/>
               </a:rPr>
@@ -14537,7 +14537,7 @@
             <a:r>
               <a:rPr sz="2700" b="1">
                 <a:solidFill>
-                  <a:srgbClr val="FFFFFF"/>
+                  <a:srgbClr val="F4F8FC"/>
                 </a:solidFill>
                 <a:latin typeface="Microsoft JhengHei"/>
               </a:rPr>
@@ -14605,7 +14605,7 @@
             <a:r>
               <a:rPr sz="1650" b="1">
                 <a:solidFill>
-                  <a:srgbClr val="FFFFFF"/>
+                  <a:srgbClr val="F4F8FC"/>
                 </a:solidFill>
                 <a:latin typeface="Microsoft JhengHei"/>
               </a:rPr>
@@ -15063,11 +15063,11 @@
             <a:r>
               <a:rPr sz="1250" b="1">
                 <a:solidFill>
-                  <a:srgbClr val="FFFFFF"/>
-                </a:solidFill>
-                <a:latin typeface="Microsoft JhengHei"/>
-              </a:rPr>
-              <a:t>LINE 提問</a:t>
+                  <a:srgbClr val="F4F8FC"/>
+                </a:solidFill>
+                <a:latin typeface="Microsoft JhengHei"/>
+              </a:rPr>
+              <a:t>使用者在 LINE 提問</a:t>
             </a:r>
           </a:p>
         </p:txBody>
@@ -15131,11 +15131,11 @@
             <a:r>
               <a:rPr sz="1250" b="1">
                 <a:solidFill>
-                  <a:srgbClr val="FFFFFF"/>
-                </a:solidFill>
-                <a:latin typeface="Microsoft JhengHei"/>
-              </a:rPr>
-              <a:t>安全與條件檢查</a:t>
+                  <a:srgbClr val="F4F8FC"/>
+                </a:solidFill>
+                <a:latin typeface="Microsoft JhengHei"/>
+              </a:rPr>
+              <a:t>確認訊息安全且符合條件</a:t>
             </a:r>
           </a:p>
         </p:txBody>
@@ -15199,7 +15199,7 @@
             <a:r>
               <a:rPr sz="1250" b="1">
                 <a:solidFill>
-                  <a:srgbClr val="FFFFFF"/>
+                  <a:srgbClr val="F4F8FC"/>
                 </a:solidFill>
                 <a:latin typeface="Microsoft JhengHei"/>
               </a:rPr>
@@ -15267,11 +15267,11 @@
             <a:r>
               <a:rPr sz="1250" b="1">
                 <a:solidFill>
-                  <a:srgbClr val="FFFFFF"/>
-                </a:solidFill>
-                <a:latin typeface="Microsoft JhengHei"/>
-              </a:rPr>
-              <a:t>查找資料</a:t>
+                  <a:srgbClr val="F4F8FC"/>
+                </a:solidFill>
+                <a:latin typeface="Microsoft JhengHei"/>
+              </a:rPr>
+              <a:t>查找資料並請 AI 整理</a:t>
             </a:r>
           </a:p>
         </p:txBody>
@@ -15335,11 +15335,11 @@
             <a:r>
               <a:rPr sz="1250" b="1">
                 <a:solidFill>
-                  <a:srgbClr val="FFFFFF"/>
-                </a:solidFill>
-                <a:latin typeface="Microsoft JhengHei"/>
-              </a:rPr>
-              <a:t>AI 整理</a:t>
+                  <a:srgbClr val="F4F8FC"/>
+                </a:solidFill>
+                <a:latin typeface="Microsoft JhengHei"/>
+              </a:rPr>
+              <a:t>把答案回傳至 LINE</a:t>
             </a:r>
           </a:p>
         </p:txBody>
@@ -15403,11 +15403,11 @@
             <a:r>
               <a:rPr sz="1250" b="1">
                 <a:solidFill>
-                  <a:srgbClr val="FFFFFF"/>
-                </a:solidFill>
-                <a:latin typeface="Microsoft JhengHei"/>
-              </a:rPr>
-              <a:t>回傳與紀錄</a:t>
+                  <a:srgbClr val="F4F8FC"/>
+                </a:solidFill>
+                <a:latin typeface="Microsoft JhengHei"/>
+              </a:rPr>
+              <a:t>留下分層管理的工作與診斷紀錄</a:t>
             </a:r>
           </a:p>
         </p:txBody>
@@ -15471,7 +15471,7 @@
             <a:r>
               <a:rPr sz="1250" b="0">
                 <a:solidFill>
-                  <a:srgbClr val="FFFFFF"/>
+                  <a:srgbClr val="F4F8FC"/>
                 </a:solidFill>
                 <a:latin typeface="Microsoft JhengHei"/>
               </a:rPr>
@@ -15539,7 +15539,7 @@
             <a:r>
               <a:rPr sz="1250" b="0">
                 <a:solidFill>
-                  <a:srgbClr val="FFFFFF"/>
+                  <a:srgbClr val="F4F8FC"/>
                 </a:solidFill>
                 <a:latin typeface="Microsoft JhengHei"/>
               </a:rPr>
@@ -15607,7 +15607,7 @@
             <a:r>
               <a:rPr sz="1320" b="0">
                 <a:solidFill>
-                  <a:srgbClr val="FFFFFF"/>
+                  <a:srgbClr val="F4F8FC"/>
                 </a:solidFill>
                 <a:latin typeface="Microsoft JhengHei"/>
               </a:rPr>
@@ -15671,7 +15671,7 @@
             <a:r>
               <a:rPr sz="950" b="1">
                 <a:solidFill>
-                  <a:srgbClr val="FFFFFF"/>
+                  <a:srgbClr val="F4F8FC"/>
                 </a:solidFill>
                 <a:latin typeface="Microsoft JhengHei"/>
               </a:rPr>
@@ -15739,7 +15739,7 @@
             <a:r>
               <a:rPr sz="1320" b="0">
                 <a:solidFill>
-                  <a:srgbClr val="FFFFFF"/>
+                  <a:srgbClr val="F4F8FC"/>
                 </a:solidFill>
                 <a:latin typeface="Microsoft JhengHei"/>
               </a:rPr>
@@ -15803,7 +15803,7 @@
             <a:r>
               <a:rPr sz="950" b="1">
                 <a:solidFill>
-                  <a:srgbClr val="FFFFFF"/>
+                  <a:srgbClr val="F4F8FC"/>
                 </a:solidFill>
                 <a:latin typeface="Microsoft JhengHei"/>
               </a:rPr>
@@ -15871,7 +15871,7 @@
             <a:r>
               <a:rPr sz="1320" b="0">
                 <a:solidFill>
-                  <a:srgbClr val="FFFFFF"/>
+                  <a:srgbClr val="F4F8FC"/>
                 </a:solidFill>
                 <a:latin typeface="Microsoft JhengHei"/>
               </a:rPr>
@@ -15935,7 +15935,7 @@
             <a:r>
               <a:rPr sz="950" b="1">
                 <a:solidFill>
-                  <a:srgbClr val="FFFFFF"/>
+                  <a:srgbClr val="F4F8FC"/>
                 </a:solidFill>
                 <a:latin typeface="Microsoft JhengHei"/>
               </a:rPr>
@@ -16003,7 +16003,7 @@
             <a:r>
               <a:rPr sz="1320" b="0">
                 <a:solidFill>
-                  <a:srgbClr val="FFFFFF"/>
+                  <a:srgbClr val="F4F8FC"/>
                 </a:solidFill>
                 <a:latin typeface="Microsoft JhengHei"/>
               </a:rPr>
@@ -16067,7 +16067,7 @@
             <a:r>
               <a:rPr sz="950" b="1">
                 <a:solidFill>
-                  <a:srgbClr val="FFFFFF"/>
+                  <a:srgbClr val="F4F8FC"/>
                 </a:solidFill>
                 <a:latin typeface="Microsoft JhengHei"/>
               </a:rPr>
@@ -16181,7 +16181,7 @@
             <a:r>
               <a:rPr sz="850" b="0">
                 <a:solidFill>
-                  <a:srgbClr val="FFFFFF"/>
+                  <a:srgbClr val="F4F8FC"/>
                 </a:solidFill>
                 <a:latin typeface="Microsoft JhengHei"/>
               </a:rPr>
@@ -16226,7 +16226,7 @@
             <a:r>
               <a:rPr sz="900" b="1">
                 <a:solidFill>
-                  <a:srgbClr val="FFFFFF"/>
+                  <a:srgbClr val="F4F8FC"/>
                 </a:solidFill>
                 <a:latin typeface="Microsoft JhengHei"/>
               </a:rPr>
@@ -16271,7 +16271,7 @@
             <a:r>
               <a:rPr sz="950" b="1">
                 <a:solidFill>
-                  <a:srgbClr val="FFFFFF"/>
+                  <a:srgbClr val="F4F8FC"/>
                 </a:solidFill>
                 <a:latin typeface="Microsoft JhengHei"/>
               </a:rPr>
@@ -16316,7 +16316,7 @@
             <a:r>
               <a:rPr sz="2700" b="1">
                 <a:solidFill>
-                  <a:srgbClr val="FFFFFF"/>
+                  <a:srgbClr val="F4F8FC"/>
                 </a:solidFill>
                 <a:latin typeface="Microsoft JhengHei"/>
               </a:rPr>
@@ -16384,7 +16384,7 @@
             <a:r>
               <a:rPr sz="1650" b="1">
                 <a:solidFill>
-                  <a:srgbClr val="FFFFFF"/>
+                  <a:srgbClr val="F4F8FC"/>
                 </a:solidFill>
                 <a:latin typeface="Microsoft JhengHei"/>
               </a:rPr>
@@ -16452,7 +16452,7 @@
             <a:r>
               <a:rPr sz="1600" b="0">
                 <a:solidFill>
-                  <a:srgbClr val="FFFFFF"/>
+                  <a:srgbClr val="F4F8FC"/>
                 </a:solidFill>
                 <a:latin typeface="Microsoft JhengHei"/>
               </a:rPr>
@@ -16516,7 +16516,7 @@
             <a:r>
               <a:rPr sz="950" b="1">
                 <a:solidFill>
-                  <a:srgbClr val="FFFFFF"/>
+                  <a:srgbClr val="F4F8FC"/>
                 </a:solidFill>
                 <a:latin typeface="Microsoft JhengHei"/>
               </a:rPr>
@@ -16584,7 +16584,7 @@
             <a:r>
               <a:rPr sz="1600" b="0">
                 <a:solidFill>
-                  <a:srgbClr val="FFFFFF"/>
+                  <a:srgbClr val="F4F8FC"/>
                 </a:solidFill>
                 <a:latin typeface="Microsoft JhengHei"/>
               </a:rPr>
@@ -16648,7 +16648,7 @@
             <a:r>
               <a:rPr sz="950" b="1">
                 <a:solidFill>
-                  <a:srgbClr val="FFFFFF"/>
+                  <a:srgbClr val="F4F8FC"/>
                 </a:solidFill>
                 <a:latin typeface="Microsoft JhengHei"/>
               </a:rPr>
@@ -16716,7 +16716,7 @@
             <a:r>
               <a:rPr sz="1600" b="0">
                 <a:solidFill>
-                  <a:srgbClr val="FFFFFF"/>
+                  <a:srgbClr val="F4F8FC"/>
                 </a:solidFill>
                 <a:latin typeface="Microsoft JhengHei"/>
               </a:rPr>
@@ -16780,7 +16780,7 @@
             <a:r>
               <a:rPr sz="950" b="1">
                 <a:solidFill>
-                  <a:srgbClr val="FFFFFF"/>
+                  <a:srgbClr val="F4F8FC"/>
                 </a:solidFill>
                 <a:latin typeface="Microsoft JhengHei"/>
               </a:rPr>
@@ -16848,7 +16848,7 @@
             <a:r>
               <a:rPr sz="1600" b="0">
                 <a:solidFill>
-                  <a:srgbClr val="FFFFFF"/>
+                  <a:srgbClr val="F4F8FC"/>
                 </a:solidFill>
                 <a:latin typeface="Microsoft JhengHei"/>
               </a:rPr>
@@ -16912,7 +16912,7 @@
             <a:r>
               <a:rPr sz="950" b="1">
                 <a:solidFill>
-                  <a:srgbClr val="FFFFFF"/>
+                  <a:srgbClr val="F4F8FC"/>
                 </a:solidFill>
                 <a:latin typeface="Microsoft JhengHei"/>
               </a:rPr>
@@ -16980,7 +16980,7 @@
             <a:r>
               <a:rPr sz="1600" b="0">
                 <a:solidFill>
-                  <a:srgbClr val="FFFFFF"/>
+                  <a:srgbClr val="F4F8FC"/>
                 </a:solidFill>
                 <a:latin typeface="Microsoft JhengHei"/>
               </a:rPr>
@@ -17044,7 +17044,7 @@
             <a:r>
               <a:rPr sz="950" b="1">
                 <a:solidFill>
-                  <a:srgbClr val="FFFFFF"/>
+                  <a:srgbClr val="F4F8FC"/>
                 </a:solidFill>
                 <a:latin typeface="Microsoft JhengHei"/>
               </a:rPr>
@@ -17158,7 +17158,7 @@
             <a:r>
               <a:rPr sz="850" b="0">
                 <a:solidFill>
-                  <a:srgbClr val="FFFFFF"/>
+                  <a:srgbClr val="F4F8FC"/>
                 </a:solidFill>
                 <a:latin typeface="Microsoft JhengHei"/>
               </a:rPr>
@@ -17203,7 +17203,7 @@
             <a:r>
               <a:rPr sz="900" b="1">
                 <a:solidFill>
-                  <a:srgbClr val="FFFFFF"/>
+                  <a:srgbClr val="F4F8FC"/>
                 </a:solidFill>
                 <a:latin typeface="Microsoft JhengHei"/>
               </a:rPr>
@@ -17248,7 +17248,7 @@
             <a:r>
               <a:rPr sz="950" b="1">
                 <a:solidFill>
-                  <a:srgbClr val="FFFFFF"/>
+                  <a:srgbClr val="F4F8FC"/>
                 </a:solidFill>
                 <a:latin typeface="Microsoft JhengHei"/>
               </a:rPr>
@@ -17293,7 +17293,7 @@
             <a:r>
               <a:rPr sz="2700" b="1">
                 <a:solidFill>
-                  <a:srgbClr val="FFFFFF"/>
+                  <a:srgbClr val="F4F8FC"/>
                 </a:solidFill>
                 <a:latin typeface="Microsoft JhengHei"/>
               </a:rPr>
@@ -17361,7 +17361,7 @@
             <a:r>
               <a:rPr sz="1650" b="1">
                 <a:solidFill>
-                  <a:srgbClr val="FFFFFF"/>
+                  <a:srgbClr val="F4F8FC"/>
                 </a:solidFill>
                 <a:latin typeface="Microsoft JhengHei"/>
               </a:rPr>
@@ -17429,7 +17429,7 @@
             <a:r>
               <a:rPr sz="1600" b="0">
                 <a:solidFill>
-                  <a:srgbClr val="FFFFFF"/>
+                  <a:srgbClr val="F4F8FC"/>
                 </a:solidFill>
                 <a:latin typeface="Microsoft JhengHei"/>
               </a:rPr>
@@ -17493,7 +17493,7 @@
             <a:r>
               <a:rPr sz="950" b="1">
                 <a:solidFill>
-                  <a:srgbClr val="FFFFFF"/>
+                  <a:srgbClr val="F4F8FC"/>
                 </a:solidFill>
                 <a:latin typeface="Microsoft JhengHei"/>
               </a:rPr>
@@ -17561,7 +17561,7 @@
             <a:r>
               <a:rPr sz="1600" b="0">
                 <a:solidFill>
-                  <a:srgbClr val="FFFFFF"/>
+                  <a:srgbClr val="F4F8FC"/>
                 </a:solidFill>
                 <a:latin typeface="Microsoft JhengHei"/>
               </a:rPr>
@@ -17625,7 +17625,7 @@
             <a:r>
               <a:rPr sz="950" b="1">
                 <a:solidFill>
-                  <a:srgbClr val="FFFFFF"/>
+                  <a:srgbClr val="F4F8FC"/>
                 </a:solidFill>
                 <a:latin typeface="Microsoft JhengHei"/>
               </a:rPr>
@@ -17693,7 +17693,7 @@
             <a:r>
               <a:rPr sz="1600" b="0">
                 <a:solidFill>
-                  <a:srgbClr val="FFFFFF"/>
+                  <a:srgbClr val="F4F8FC"/>
                 </a:solidFill>
                 <a:latin typeface="Microsoft JhengHei"/>
               </a:rPr>
@@ -17757,7 +17757,7 @@
             <a:r>
               <a:rPr sz="950" b="1">
                 <a:solidFill>
-                  <a:srgbClr val="FFFFFF"/>
+                  <a:srgbClr val="F4F8FC"/>
                 </a:solidFill>
                 <a:latin typeface="Microsoft JhengHei"/>
               </a:rPr>
@@ -17825,7 +17825,7 @@
             <a:r>
               <a:rPr sz="1600" b="0">
                 <a:solidFill>
-                  <a:srgbClr val="FFFFFF"/>
+                  <a:srgbClr val="F4F8FC"/>
                 </a:solidFill>
                 <a:latin typeface="Microsoft JhengHei"/>
               </a:rPr>
@@ -17889,7 +17889,7 @@
             <a:r>
               <a:rPr sz="950" b="1">
                 <a:solidFill>
-                  <a:srgbClr val="FFFFFF"/>
+                  <a:srgbClr val="F4F8FC"/>
                 </a:solidFill>
                 <a:latin typeface="Microsoft JhengHei"/>
               </a:rPr>
@@ -18003,7 +18003,7 @@
             <a:r>
               <a:rPr sz="850" b="0">
                 <a:solidFill>
-                  <a:srgbClr val="FFFFFF"/>
+                  <a:srgbClr val="F4F8FC"/>
                 </a:solidFill>
                 <a:latin typeface="Microsoft JhengHei"/>
               </a:rPr>
@@ -18048,7 +18048,7 @@
             <a:r>
               <a:rPr sz="900" b="1">
                 <a:solidFill>
-                  <a:srgbClr val="FFFFFF"/>
+                  <a:srgbClr val="F4F8FC"/>
                 </a:solidFill>
                 <a:latin typeface="Microsoft JhengHei"/>
               </a:rPr>
@@ -18093,7 +18093,7 @@
             <a:r>
               <a:rPr sz="950" b="1">
                 <a:solidFill>
-                  <a:srgbClr val="FFFFFF"/>
+                  <a:srgbClr val="F4F8FC"/>
                 </a:solidFill>
                 <a:latin typeface="Microsoft JhengHei"/>
               </a:rPr>
@@ -18138,7 +18138,7 @@
             <a:r>
               <a:rPr sz="2700" b="1">
                 <a:solidFill>
-                  <a:srgbClr val="FFFFFF"/>
+                  <a:srgbClr val="F4F8FC"/>
                 </a:solidFill>
                 <a:latin typeface="Microsoft JhengHei"/>
               </a:rPr>
@@ -18206,7 +18206,7 @@
             <a:r>
               <a:rPr sz="1650" b="1">
                 <a:solidFill>
-                  <a:srgbClr val="FFFFFF"/>
+                  <a:srgbClr val="F4F8FC"/>
                 </a:solidFill>
                 <a:latin typeface="Microsoft JhengHei"/>
               </a:rPr>
@@ -18274,7 +18274,7 @@
             <a:r>
               <a:rPr sz="1600" b="0">
                 <a:solidFill>
-                  <a:srgbClr val="FFFFFF"/>
+                  <a:srgbClr val="F4F8FC"/>
                 </a:solidFill>
                 <a:latin typeface="Microsoft JhengHei"/>
               </a:rPr>
@@ -18338,7 +18338,7 @@
             <a:r>
               <a:rPr sz="950" b="1">
                 <a:solidFill>
-                  <a:srgbClr val="FFFFFF"/>
+                  <a:srgbClr val="F4F8FC"/>
                 </a:solidFill>
                 <a:latin typeface="Microsoft JhengHei"/>
               </a:rPr>
@@ -18406,7 +18406,7 @@
             <a:r>
               <a:rPr sz="1600" b="0">
                 <a:solidFill>
-                  <a:srgbClr val="FFFFFF"/>
+                  <a:srgbClr val="F4F8FC"/>
                 </a:solidFill>
                 <a:latin typeface="Microsoft JhengHei"/>
               </a:rPr>
@@ -18470,7 +18470,7 @@
             <a:r>
               <a:rPr sz="950" b="1">
                 <a:solidFill>
-                  <a:srgbClr val="FFFFFF"/>
+                  <a:srgbClr val="F4F8FC"/>
                 </a:solidFill>
                 <a:latin typeface="Microsoft JhengHei"/>
               </a:rPr>
@@ -18538,7 +18538,7 @@
             <a:r>
               <a:rPr sz="1600" b="0">
                 <a:solidFill>
-                  <a:srgbClr val="FFFFFF"/>
+                  <a:srgbClr val="F4F8FC"/>
                 </a:solidFill>
                 <a:latin typeface="Microsoft JhengHei"/>
               </a:rPr>
@@ -18602,7 +18602,7 @@
             <a:r>
               <a:rPr sz="950" b="1">
                 <a:solidFill>
-                  <a:srgbClr val="FFFFFF"/>
+                  <a:srgbClr val="F4F8FC"/>
                 </a:solidFill>
                 <a:latin typeface="Microsoft JhengHei"/>
               </a:rPr>
@@ -18670,7 +18670,7 @@
             <a:r>
               <a:rPr sz="1600" b="0">
                 <a:solidFill>
-                  <a:srgbClr val="FFFFFF"/>
+                  <a:srgbClr val="F4F8FC"/>
                 </a:solidFill>
                 <a:latin typeface="Microsoft JhengHei"/>
               </a:rPr>
@@ -18734,7 +18734,7 @@
             <a:r>
               <a:rPr sz="950" b="1">
                 <a:solidFill>
-                  <a:srgbClr val="FFFFFF"/>
+                  <a:srgbClr val="F4F8FC"/>
                 </a:solidFill>
                 <a:latin typeface="Microsoft JhengHei"/>
               </a:rPr>
@@ -18848,7 +18848,7 @@
             <a:r>
               <a:rPr sz="850" b="0">
                 <a:solidFill>
-                  <a:srgbClr val="FFFFFF"/>
+                  <a:srgbClr val="F4F8FC"/>
                 </a:solidFill>
                 <a:latin typeface="Microsoft JhengHei"/>
               </a:rPr>
@@ -18893,7 +18893,7 @@
             <a:r>
               <a:rPr sz="900" b="1">
                 <a:solidFill>
-                  <a:srgbClr val="FFFFFF"/>
+                  <a:srgbClr val="F4F8FC"/>
                 </a:solidFill>
                 <a:latin typeface="Microsoft JhengHei"/>
               </a:rPr>
@@ -18938,7 +18938,7 @@
             <a:r>
               <a:rPr sz="950" b="1">
                 <a:solidFill>
-                  <a:srgbClr val="FFFFFF"/>
+                  <a:srgbClr val="F4F8FC"/>
                 </a:solidFill>
                 <a:latin typeface="Microsoft JhengHei"/>
               </a:rPr>
@@ -18983,7 +18983,7 @@
             <a:r>
               <a:rPr sz="2700" b="1">
                 <a:solidFill>
-                  <a:srgbClr val="FFFFFF"/>
+                  <a:srgbClr val="F4F8FC"/>
                 </a:solidFill>
                 <a:latin typeface="Microsoft JhengHei"/>
               </a:rPr>
@@ -19051,7 +19051,7 @@
             <a:r>
               <a:rPr sz="1650" b="1">
                 <a:solidFill>
-                  <a:srgbClr val="FFFFFF"/>
+                  <a:srgbClr val="F4F8FC"/>
                 </a:solidFill>
                 <a:latin typeface="Microsoft JhengHei"/>
               </a:rPr>
@@ -19119,7 +19119,7 @@
             <a:r>
               <a:rPr sz="1150" b="0">
                 <a:solidFill>
-                  <a:srgbClr val="FFFFFF"/>
+                  <a:srgbClr val="F4F8FC"/>
                 </a:solidFill>
                 <a:latin typeface="Microsoft JhengHei"/>
               </a:rPr>
@@ -19187,7 +19187,7 @@
             <a:r>
               <a:rPr sz="1150" b="0">
                 <a:solidFill>
-                  <a:srgbClr val="FFFFFF"/>
+                  <a:srgbClr val="F4F8FC"/>
                 </a:solidFill>
                 <a:latin typeface="Microsoft JhengHei"/>
               </a:rPr>
@@ -19255,7 +19255,7 @@
             <a:r>
               <a:rPr sz="1150" b="0">
                 <a:solidFill>
-                  <a:srgbClr val="FFFFFF"/>
+                  <a:srgbClr val="F4F8FC"/>
                 </a:solidFill>
                 <a:latin typeface="Microsoft JhengHei"/>
               </a:rPr>
@@ -19300,7 +19300,7 @@
             <a:r>
               <a:rPr sz="1200" b="1">
                 <a:solidFill>
-                  <a:srgbClr val="FFFFFF"/>
+                  <a:srgbClr val="F4F8FC"/>
                 </a:solidFill>
                 <a:latin typeface="Microsoft JhengHei"/>
               </a:rPr>
@@ -19368,7 +19368,7 @@
             <a:r>
               <a:rPr sz="1050" b="1">
                 <a:solidFill>
-                  <a:srgbClr val="FFFFFF"/>
+                  <a:srgbClr val="F4F8FC"/>
                 </a:solidFill>
                 <a:latin typeface="Microsoft JhengHei"/>
               </a:rPr>
@@ -19437,7 +19437,7 @@
             <a:r>
               <a:rPr sz="1050" b="1">
                 <a:solidFill>
-                  <a:srgbClr val="FFFFFF"/>
+                  <a:srgbClr val="F4F8FC"/>
                 </a:solidFill>
                 <a:latin typeface="Microsoft JhengHei"/>
               </a:rPr>
@@ -19506,7 +19506,7 @@
             <a:r>
               <a:rPr sz="1050" b="1">
                 <a:solidFill>
-                  <a:srgbClr val="FFFFFF"/>
+                  <a:srgbClr val="F4F8FC"/>
                 </a:solidFill>
                 <a:latin typeface="Microsoft JhengHei"/>
               </a:rPr>
@@ -19575,7 +19575,7 @@
             <a:r>
               <a:rPr sz="1050" b="1">
                 <a:solidFill>
-                  <a:srgbClr val="FFFFFF"/>
+                  <a:srgbClr val="F4F8FC"/>
                 </a:solidFill>
                 <a:latin typeface="Microsoft JhengHei"/>
               </a:rPr>
@@ -19644,7 +19644,7 @@
             <a:r>
               <a:rPr sz="1050" b="1">
                 <a:solidFill>
-                  <a:srgbClr val="FFFFFF"/>
+                  <a:srgbClr val="F4F8FC"/>
                 </a:solidFill>
                 <a:latin typeface="Microsoft JhengHei"/>
               </a:rPr>
@@ -19713,7 +19713,7 @@
             <a:r>
               <a:rPr sz="1050" b="1">
                 <a:solidFill>
-                  <a:srgbClr val="FFFFFF"/>
+                  <a:srgbClr val="F4F8FC"/>
                 </a:solidFill>
                 <a:latin typeface="Microsoft JhengHei"/>
               </a:rPr>
@@ -19782,7 +19782,7 @@
             <a:r>
               <a:rPr sz="1050" b="1">
                 <a:solidFill>
-                  <a:srgbClr val="FFFFFF"/>
+                  <a:srgbClr val="F4F8FC"/>
                 </a:solidFill>
                 <a:latin typeface="Microsoft JhengHei"/>
               </a:rPr>
@@ -19828,7 +19828,7 @@
             <a:r>
               <a:rPr sz="1200" b="1">
                 <a:solidFill>
-                  <a:srgbClr val="FFFFFF"/>
+                  <a:srgbClr val="F4F8FC"/>
                 </a:solidFill>
                 <a:latin typeface="Microsoft JhengHei"/>
               </a:rPr>
@@ -19896,7 +19896,7 @@
             <a:r>
               <a:rPr sz="1300" b="1">
                 <a:solidFill>
-                  <a:srgbClr val="FFFFFF"/>
+                  <a:srgbClr val="F4F8FC"/>
                 </a:solidFill>
                 <a:latin typeface="Microsoft JhengHei"/>
               </a:rPr>
@@ -19965,7 +19965,7 @@
             <a:r>
               <a:rPr sz="1300" b="1">
                 <a:solidFill>
-                  <a:srgbClr val="FFFFFF"/>
+                  <a:srgbClr val="F4F8FC"/>
                 </a:solidFill>
                 <a:latin typeface="Microsoft JhengHei"/>
               </a:rPr>
@@ -20034,7 +20034,7 @@
             <a:r>
               <a:rPr sz="1300" b="1">
                 <a:solidFill>
-                  <a:srgbClr val="FFFFFF"/>
+                  <a:srgbClr val="F4F8FC"/>
                 </a:solidFill>
                 <a:latin typeface="Microsoft JhengHei"/>
               </a:rPr>
@@ -20080,7 +20080,7 @@
             <a:r>
               <a:rPr sz="1200" b="1">
                 <a:solidFill>
-                  <a:srgbClr val="FFFFFF"/>
+                  <a:srgbClr val="F4F8FC"/>
                 </a:solidFill>
                 <a:latin typeface="Microsoft JhengHei"/>
               </a:rPr>
@@ -20148,7 +20148,7 @@
             <a:r>
               <a:rPr sz="1300" b="1">
                 <a:solidFill>
-                  <a:srgbClr val="FFFFFF"/>
+                  <a:srgbClr val="F4F8FC"/>
                 </a:solidFill>
                 <a:latin typeface="Microsoft JhengHei"/>
               </a:rPr>
@@ -20217,7 +20217,7 @@
             <a:r>
               <a:rPr sz="1300" b="1">
                 <a:solidFill>
-                  <a:srgbClr val="FFFFFF"/>
+                  <a:srgbClr val="F4F8FC"/>
                 </a:solidFill>
                 <a:latin typeface="Microsoft JhengHei"/>
               </a:rPr>
@@ -20286,7 +20286,7 @@
             <a:r>
               <a:rPr sz="1300" b="1">
                 <a:solidFill>
-                  <a:srgbClr val="FFFFFF"/>
+                  <a:srgbClr val="F4F8FC"/>
                 </a:solidFill>
                 <a:latin typeface="Microsoft JhengHei"/>
               </a:rPr>

</xml_diff>

<commit_message>
docs: finalize client PowerPoint delivery
</commit_message>
<xml_diff>
--- a/docs/presentations/AI-ChotBot-project-progress-client.pptx
+++ b/docs/presentations/AI-ChotBot-project-progress-client.pptx
@@ -4858,7 +4858,7 @@
               </a:spcAft>
             </a:pPr>
             <a:r>
-              <a:rPr sz="1500" b="1">
+              <a:rPr sz="1600" b="1">
                 <a:solidFill>
                   <a:srgbClr val="F4F8FC"/>
                 </a:solidFill>
@@ -4926,7 +4926,7 @@
               </a:spcAft>
             </a:pPr>
             <a:r>
-              <a:rPr sz="1400" b="0">
+              <a:rPr sz="1600" b="0">
                 <a:solidFill>
                   <a:srgbClr val="F4F8FC"/>
                 </a:solidFill>
@@ -4994,7 +4994,7 @@
               </a:spcAft>
             </a:pPr>
             <a:r>
-              <a:rPr sz="1400" b="0">
+              <a:rPr sz="1600" b="0">
                 <a:solidFill>
                   <a:srgbClr val="F4F8FC"/>
                 </a:solidFill>
@@ -5062,7 +5062,7 @@
               </a:spcAft>
             </a:pPr>
             <a:r>
-              <a:rPr sz="1400" b="0">
+              <a:rPr sz="1600" b="0">
                 <a:solidFill>
                   <a:srgbClr val="F4F8FC"/>
                 </a:solidFill>
@@ -6900,7 +6900,7 @@
               </a:spcAft>
             </a:pPr>
             <a:r>
-              <a:rPr sz="1430" b="0">
+              <a:rPr sz="1600" b="0">
                 <a:solidFill>
                   <a:srgbClr val="F4F8FC"/>
                 </a:solidFill>
@@ -7032,7 +7032,7 @@
               </a:spcAft>
             </a:pPr>
             <a:r>
-              <a:rPr sz="1430" b="0">
+              <a:rPr sz="1600" b="0">
                 <a:solidFill>
                   <a:srgbClr val="F4F8FC"/>
                 </a:solidFill>
@@ -7164,7 +7164,7 @@
               </a:spcAft>
             </a:pPr>
             <a:r>
-              <a:rPr sz="1430" b="0">
+              <a:rPr sz="1600" b="0">
                 <a:solidFill>
                   <a:srgbClr val="F4F8FC"/>
                 </a:solidFill>
@@ -7296,7 +7296,7 @@
               </a:spcAft>
             </a:pPr>
             <a:r>
-              <a:rPr sz="1430" b="0">
+              <a:rPr sz="1600" b="0">
                 <a:solidFill>
                   <a:srgbClr val="F4F8FC"/>
                 </a:solidFill>
@@ -7428,7 +7428,7 @@
               </a:spcAft>
             </a:pPr>
             <a:r>
-              <a:rPr sz="1430" b="0">
+              <a:rPr sz="1600" b="0">
                 <a:solidFill>
                   <a:srgbClr val="F4F8FC"/>
                 </a:solidFill>
@@ -8149,7 +8149,7 @@
               </a:spcAft>
             </a:pPr>
             <a:r>
-              <a:rPr sz="1430" b="0">
+              <a:rPr sz="1600" b="0">
                 <a:solidFill>
                   <a:srgbClr val="F4F8FC"/>
                 </a:solidFill>
@@ -8281,7 +8281,7 @@
               </a:spcAft>
             </a:pPr>
             <a:r>
-              <a:rPr sz="1430" b="0">
+              <a:rPr sz="1600" b="0">
                 <a:solidFill>
                   <a:srgbClr val="F4F8FC"/>
                 </a:solidFill>
@@ -8413,7 +8413,7 @@
               </a:spcAft>
             </a:pPr>
             <a:r>
-              <a:rPr sz="1430" b="0">
+              <a:rPr sz="1600" b="0">
                 <a:solidFill>
                   <a:srgbClr val="F4F8FC"/>
                 </a:solidFill>
@@ -8545,7 +8545,7 @@
               </a:spcAft>
             </a:pPr>
             <a:r>
-              <a:rPr sz="1430" b="0">
+              <a:rPr sz="1600" b="0">
                 <a:solidFill>
                   <a:srgbClr val="F4F8FC"/>
                 </a:solidFill>
@@ -8677,7 +8677,7 @@
               </a:spcAft>
             </a:pPr>
             <a:r>
-              <a:rPr sz="1430" b="0">
+              <a:rPr sz="1600" b="0">
                 <a:solidFill>
                   <a:srgbClr val="F4F8FC"/>
                 </a:solidFill>
@@ -9398,7 +9398,7 @@
               </a:spcAft>
             </a:pPr>
             <a:r>
-              <a:rPr sz="1430" b="0">
+              <a:rPr sz="1600" b="0">
                 <a:solidFill>
                   <a:srgbClr val="F4F8FC"/>
                 </a:solidFill>
@@ -9530,7 +9530,7 @@
               </a:spcAft>
             </a:pPr>
             <a:r>
-              <a:rPr sz="1430" b="0">
+              <a:rPr sz="1600" b="0">
                 <a:solidFill>
                   <a:srgbClr val="F4F8FC"/>
                 </a:solidFill>
@@ -9662,7 +9662,7 @@
               </a:spcAft>
             </a:pPr>
             <a:r>
-              <a:rPr sz="1430" b="0">
+              <a:rPr sz="1600" b="0">
                 <a:solidFill>
                   <a:srgbClr val="F4F8FC"/>
                 </a:solidFill>
@@ -9794,7 +9794,7 @@
               </a:spcAft>
             </a:pPr>
             <a:r>
-              <a:rPr sz="1430" b="0">
+              <a:rPr sz="1600" b="0">
                 <a:solidFill>
                   <a:srgbClr val="F4F8FC"/>
                 </a:solidFill>
@@ -9926,7 +9926,7 @@
               </a:spcAft>
             </a:pPr>
             <a:r>
-              <a:rPr sz="1430" b="0">
+              <a:rPr sz="1600" b="0">
                 <a:solidFill>
                   <a:srgbClr val="F4F8FC"/>
                 </a:solidFill>
@@ -11027,7 +11027,7 @@
               </a:spcAft>
             </a:pPr>
             <a:r>
-              <a:rPr sz="1250" b="0">
+              <a:rPr sz="1600" b="0">
                 <a:solidFill>
                   <a:srgbClr val="F4F8FC"/>
                 </a:solidFill>
@@ -11159,7 +11159,7 @@
               </a:spcAft>
             </a:pPr>
             <a:r>
-              <a:rPr sz="1250" b="0">
+              <a:rPr sz="1600" b="0">
                 <a:solidFill>
                   <a:srgbClr val="F4F8FC"/>
                 </a:solidFill>
@@ -11291,7 +11291,7 @@
               </a:spcAft>
             </a:pPr>
             <a:r>
-              <a:rPr sz="1250" b="0">
+              <a:rPr sz="1600" b="0">
                 <a:solidFill>
                   <a:srgbClr val="F4F8FC"/>
                 </a:solidFill>
@@ -11423,7 +11423,7 @@
               </a:spcAft>
             </a:pPr>
             <a:r>
-              <a:rPr sz="1250" b="0">
+              <a:rPr sz="1600" b="0">
                 <a:solidFill>
                   <a:srgbClr val="F4F8FC"/>
                 </a:solidFill>
@@ -11555,7 +11555,7 @@
               </a:spcAft>
             </a:pPr>
             <a:r>
-              <a:rPr sz="1250" b="0">
+              <a:rPr sz="1600" b="0">
                 <a:solidFill>
                   <a:srgbClr val="F4F8FC"/>
                 </a:solidFill>
@@ -15605,7 +15605,7 @@
               </a:spcAft>
             </a:pPr>
             <a:r>
-              <a:rPr sz="1320" b="0">
+              <a:rPr sz="1600" b="0">
                 <a:solidFill>
                   <a:srgbClr val="F4F8FC"/>
                 </a:solidFill>
@@ -15737,7 +15737,7 @@
               </a:spcAft>
             </a:pPr>
             <a:r>
-              <a:rPr sz="1320" b="0">
+              <a:rPr sz="1600" b="0">
                 <a:solidFill>
                   <a:srgbClr val="F4F8FC"/>
                 </a:solidFill>
@@ -15869,7 +15869,7 @@
               </a:spcAft>
             </a:pPr>
             <a:r>
-              <a:rPr sz="1320" b="0">
+              <a:rPr sz="1600" b="0">
                 <a:solidFill>
                   <a:srgbClr val="F4F8FC"/>
                 </a:solidFill>
@@ -16001,7 +16001,7 @@
               </a:spcAft>
             </a:pPr>
             <a:r>
-              <a:rPr sz="1320" b="0">
+              <a:rPr sz="1600" b="0">
                 <a:solidFill>
                   <a:srgbClr val="F4F8FC"/>
                 </a:solidFill>
@@ -19069,7 +19069,7 @@
         <p:spPr>
           <a:xfrm>
             <a:off x="658368" y="1901952"/>
-            <a:ext cx="3474720" cy="548640"/>
+            <a:ext cx="3474720" cy="749808"/>
           </a:xfrm>
           <a:prstGeom prst="roundRect">
             <a:avLst>
@@ -19117,7 +19117,7 @@
               </a:spcAft>
             </a:pPr>
             <a:r>
-              <a:rPr sz="1150" b="0">
+              <a:rPr sz="1600" b="0">
                 <a:solidFill>
                   <a:srgbClr val="F4F8FC"/>
                 </a:solidFill>
@@ -19137,7 +19137,7 @@
         <p:spPr>
           <a:xfrm>
             <a:off x="4343400" y="1901952"/>
-            <a:ext cx="3474720" cy="548640"/>
+            <a:ext cx="3474720" cy="749808"/>
           </a:xfrm>
           <a:prstGeom prst="roundRect">
             <a:avLst>
@@ -19185,7 +19185,7 @@
               </a:spcAft>
             </a:pPr>
             <a:r>
-              <a:rPr sz="1150" b="0">
+              <a:rPr sz="1600" b="0">
                 <a:solidFill>
                   <a:srgbClr val="F4F8FC"/>
                 </a:solidFill>
@@ -19205,7 +19205,7 @@
         <p:spPr>
           <a:xfrm>
             <a:off x="8028432" y="1901952"/>
-            <a:ext cx="3474720" cy="548640"/>
+            <a:ext cx="3474720" cy="749808"/>
           </a:xfrm>
           <a:prstGeom prst="roundRect">
             <a:avLst>
@@ -19253,7 +19253,7 @@
               </a:spcAft>
             </a:pPr>
             <a:r>
-              <a:rPr sz="1150" b="0">
+              <a:rPr sz="1600" b="0">
                 <a:solidFill>
                   <a:srgbClr val="F4F8FC"/>
                 </a:solidFill>
@@ -19272,7 +19272,7 @@
         </p:nvSpPr>
         <p:spPr>
           <a:xfrm>
-            <a:off x="658368" y="2587752"/>
+            <a:off x="658368" y="2788920"/>
             <a:ext cx="3474720" cy="292608"/>
           </a:xfrm>
           <a:prstGeom prst="rect">
@@ -19317,8 +19317,8 @@
         </p:nvSpPr>
         <p:spPr>
           <a:xfrm>
-            <a:off x="658368" y="2944368"/>
-            <a:ext cx="3474720" cy="410173"/>
+            <a:off x="658368" y="3145536"/>
+            <a:ext cx="3474720" cy="381435"/>
           </a:xfrm>
           <a:prstGeom prst="roundRect">
             <a:avLst>
@@ -19386,8 +19386,8 @@
         </p:nvSpPr>
         <p:spPr>
           <a:xfrm>
-            <a:off x="658368" y="3427693"/>
-            <a:ext cx="3474720" cy="410173"/>
+            <a:off x="658368" y="3600123"/>
+            <a:ext cx="3474720" cy="381435"/>
           </a:xfrm>
           <a:prstGeom prst="roundRect">
             <a:avLst>
@@ -19455,8 +19455,8 @@
         </p:nvSpPr>
         <p:spPr>
           <a:xfrm>
-            <a:off x="658368" y="3911019"/>
-            <a:ext cx="3474720" cy="410173"/>
+            <a:off x="658368" y="4054710"/>
+            <a:ext cx="3474720" cy="381435"/>
           </a:xfrm>
           <a:prstGeom prst="roundRect">
             <a:avLst>
@@ -19524,8 +19524,8 @@
         </p:nvSpPr>
         <p:spPr>
           <a:xfrm>
-            <a:off x="658368" y="4394345"/>
-            <a:ext cx="3474720" cy="410173"/>
+            <a:off x="658368" y="4509298"/>
+            <a:ext cx="3474720" cy="381435"/>
           </a:xfrm>
           <a:prstGeom prst="roundRect">
             <a:avLst>
@@ -19593,8 +19593,8 @@
         </p:nvSpPr>
         <p:spPr>
           <a:xfrm>
-            <a:off x="658368" y="4877670"/>
-            <a:ext cx="3474720" cy="410173"/>
+            <a:off x="658368" y="4963885"/>
+            <a:ext cx="3474720" cy="381435"/>
           </a:xfrm>
           <a:prstGeom prst="roundRect">
             <a:avLst>
@@ -19662,8 +19662,8 @@
         </p:nvSpPr>
         <p:spPr>
           <a:xfrm>
-            <a:off x="658368" y="5360996"/>
-            <a:ext cx="3474720" cy="410173"/>
+            <a:off x="658368" y="5418473"/>
+            <a:ext cx="3474720" cy="381435"/>
           </a:xfrm>
           <a:prstGeom prst="roundRect">
             <a:avLst>
@@ -19731,8 +19731,8 @@
         </p:nvSpPr>
         <p:spPr>
           <a:xfrm>
-            <a:off x="658368" y="5844322"/>
-            <a:ext cx="3474720" cy="410173"/>
+            <a:off x="658368" y="5873060"/>
+            <a:ext cx="3474720" cy="381435"/>
           </a:xfrm>
           <a:prstGeom prst="roundRect">
             <a:avLst>
@@ -19800,7 +19800,7 @@
         </p:nvSpPr>
         <p:spPr>
           <a:xfrm>
-            <a:off x="4343400" y="2587752"/>
+            <a:off x="4343400" y="2788920"/>
             <a:ext cx="3474720" cy="292608"/>
           </a:xfrm>
           <a:prstGeom prst="rect">
@@ -19845,8 +19845,8 @@
         </p:nvSpPr>
         <p:spPr>
           <a:xfrm>
-            <a:off x="4343400" y="2944368"/>
-            <a:ext cx="3474720" cy="1054608"/>
+            <a:off x="4343400" y="3145536"/>
+            <a:ext cx="3474720" cy="987551"/>
           </a:xfrm>
           <a:prstGeom prst="roundRect">
             <a:avLst>
@@ -19914,8 +19914,8 @@
         </p:nvSpPr>
         <p:spPr>
           <a:xfrm>
-            <a:off x="4343400" y="4072128"/>
-            <a:ext cx="3474720" cy="1054608"/>
+            <a:off x="4343400" y="4206240"/>
+            <a:ext cx="3474720" cy="987551"/>
           </a:xfrm>
           <a:prstGeom prst="roundRect">
             <a:avLst>
@@ -19983,8 +19983,8 @@
         </p:nvSpPr>
         <p:spPr>
           <a:xfrm>
-            <a:off x="4343400" y="5199888"/>
-            <a:ext cx="3474720" cy="1054608"/>
+            <a:off x="4343400" y="5266944"/>
+            <a:ext cx="3474720" cy="987551"/>
           </a:xfrm>
           <a:prstGeom prst="roundRect">
             <a:avLst>
@@ -20052,7 +20052,7 @@
         </p:nvSpPr>
         <p:spPr>
           <a:xfrm>
-            <a:off x="8028431" y="2587752"/>
+            <a:off x="8028431" y="2788920"/>
             <a:ext cx="3474720" cy="292608"/>
           </a:xfrm>
           <a:prstGeom prst="rect">
@@ -20097,8 +20097,8 @@
         </p:nvSpPr>
         <p:spPr>
           <a:xfrm>
-            <a:off x="8028431" y="2944368"/>
-            <a:ext cx="3474720" cy="1054608"/>
+            <a:off x="8028431" y="3145536"/>
+            <a:ext cx="3474720" cy="987551"/>
           </a:xfrm>
           <a:prstGeom prst="roundRect">
             <a:avLst>
@@ -20166,8 +20166,8 @@
         </p:nvSpPr>
         <p:spPr>
           <a:xfrm>
-            <a:off x="8028431" y="4072128"/>
-            <a:ext cx="3474720" cy="1054608"/>
+            <a:off x="8028431" y="4206240"/>
+            <a:ext cx="3474720" cy="987551"/>
           </a:xfrm>
           <a:prstGeom prst="roundRect">
             <a:avLst>
@@ -20235,8 +20235,8 @@
         </p:nvSpPr>
         <p:spPr>
           <a:xfrm>
-            <a:off x="8028431" y="5199888"/>
-            <a:ext cx="3474720" cy="1054608"/>
+            <a:off x="8028431" y="5266944"/>
+            <a:ext cx="3474720" cy="987551"/>
           </a:xfrm>
           <a:prstGeom prst="roundRect">
             <a:avLst>

</xml_diff>

<commit_message>
fix: strengthen PowerPoint delivery validation
</commit_message>
<xml_diff>
--- a/docs/presentations/AI-ChotBot-project-progress-client.pptx
+++ b/docs/presentations/AI-ChotBot-project-progress-client.pptx
@@ -10687,13 +10687,13 @@
               </a:spcAft>
             </a:pPr>
             <a:r>
-              <a:rPr sz="1050" b="1">
-                <a:solidFill>
-                  <a:srgbClr val="F4F8FC"/>
-                </a:solidFill>
-                <a:latin typeface="Microsoft JhengHei"/>
-              </a:rPr>
-              <a:t>1. 完成分支：收斂知識搜尋、清理文件中文亂碼與平行部署副本</a:t>
+              <a:rPr sz="1600" b="1">
+                <a:solidFill>
+                  <a:srgbClr val="F4F8FC"/>
+                </a:solidFill>
+                <a:latin typeface="Microsoft JhengHei"/>
+              </a:rPr>
+              <a:t>1 完成分支</a:t>
             </a:r>
           </a:p>
         </p:txBody>
@@ -10755,13 +10755,13 @@
               </a:spcAft>
             </a:pPr>
             <a:r>
-              <a:rPr sz="1050" b="1">
-                <a:solidFill>
-                  <a:srgbClr val="F4F8FC"/>
-                </a:solidFill>
-                <a:latin typeface="Microsoft JhengHei"/>
-              </a:rPr>
-              <a:t>2. 自動化驗證：修正完整流程測試逾時，更新雲端服務設定的檢查定義後，通過完整測試與上線前自動檢查</a:t>
+              <a:rPr sz="1600" b="1">
+                <a:solidFill>
+                  <a:srgbClr val="F4F8FC"/>
+                </a:solidFill>
+                <a:latin typeface="Microsoft JhengHei"/>
+              </a:rPr>
+              <a:t>2 自動化驗證</a:t>
             </a:r>
           </a:p>
         </p:txBody>
@@ -10823,13 +10823,13 @@
               </a:spcAft>
             </a:pPr>
             <a:r>
-              <a:rPr sz="1050" b="1">
-                <a:solidFill>
-                  <a:srgbClr val="F4F8FC"/>
-                </a:solidFill>
-                <a:latin typeface="Microsoft JhengHei"/>
-              </a:rPr>
-              <a:t>3. 合併：審查後納入正式主線</a:t>
+              <a:rPr sz="1600" b="1">
+                <a:solidFill>
+                  <a:srgbClr val="F4F8FC"/>
+                </a:solidFill>
+                <a:latin typeface="Microsoft JhengHei"/>
+              </a:rPr>
+              <a:t>3 合併</a:t>
             </a:r>
           </a:p>
         </p:txBody>
@@ -10891,13 +10891,13 @@
               </a:spcAft>
             </a:pPr>
             <a:r>
-              <a:rPr sz="1050" b="1">
-                <a:solidFill>
-                  <a:srgbClr val="F4F8FC"/>
-                </a:solidFill>
-                <a:latin typeface="Microsoft JhengHei"/>
-              </a:rPr>
-              <a:t>4. 正式部署：發布設定完整的版本</a:t>
+              <a:rPr sz="1600" b="1">
+                <a:solidFill>
+                  <a:srgbClr val="F4F8FC"/>
+                </a:solidFill>
+                <a:latin typeface="Microsoft JhengHei"/>
+              </a:rPr>
+              <a:t>4 正式部署</a:t>
             </a:r>
           </a:p>
         </p:txBody>
@@ -10959,13 +10959,13 @@
               </a:spcAft>
             </a:pPr>
             <a:r>
-              <a:rPr sz="1050" b="1">
-                <a:solidFill>
-                  <a:srgbClr val="F4F8FC"/>
-                </a:solidFill>
-                <a:latin typeface="Microsoft JhengHei"/>
-              </a:rPr>
-              <a:t>5. 實機驗收：用 LINE 完成端到端確認</a:t>
+              <a:rPr sz="1600" b="1">
+                <a:solidFill>
+                  <a:srgbClr val="F4F8FC"/>
+                </a:solidFill>
+                <a:latin typeface="Microsoft JhengHei"/>
+              </a:rPr>
+              <a:t>5 實機驗收</a:t>
             </a:r>
           </a:p>
         </p:txBody>
@@ -19266,7 +19266,7 @@
       </p:sp>
       <p:sp>
         <p:nvSpPr>
-          <p:cNvPr id="11" name="technology-group-"/>
+          <p:cNvPr id="11" name="technology-group-core-capabilities"/>
           <p:cNvSpPr txBox="1"/>
           <p:nvPr/>
         </p:nvSpPr>
@@ -19366,7 +19366,7 @@
               </a:spcAft>
             </a:pPr>
             <a:r>
-              <a:rPr sz="1050" b="1">
+              <a:rPr sz="1200" b="1">
                 <a:solidFill>
                   <a:srgbClr val="F4F8FC"/>
                 </a:solidFill>
@@ -19435,7 +19435,7 @@
               </a:spcAft>
             </a:pPr>
             <a:r>
-              <a:rPr sz="1050" b="1">
+              <a:rPr sz="1200" b="1">
                 <a:solidFill>
                   <a:srgbClr val="F4F8FC"/>
                 </a:solidFill>
@@ -19504,7 +19504,7 @@
               </a:spcAft>
             </a:pPr>
             <a:r>
-              <a:rPr sz="1050" b="1">
+              <a:rPr sz="1200" b="1">
                 <a:solidFill>
                   <a:srgbClr val="F4F8FC"/>
                 </a:solidFill>
@@ -19573,7 +19573,7 @@
               </a:spcAft>
             </a:pPr>
             <a:r>
-              <a:rPr sz="1050" b="1">
+              <a:rPr sz="1200" b="1">
                 <a:solidFill>
                   <a:srgbClr val="F4F8FC"/>
                 </a:solidFill>
@@ -19642,7 +19642,7 @@
               </a:spcAft>
             </a:pPr>
             <a:r>
-              <a:rPr sz="1050" b="1">
+              <a:rPr sz="1200" b="1">
                 <a:solidFill>
                   <a:srgbClr val="F4F8FC"/>
                 </a:solidFill>
@@ -19711,7 +19711,7 @@
               </a:spcAft>
             </a:pPr>
             <a:r>
-              <a:rPr sz="1050" b="1">
+              <a:rPr sz="1200" b="1">
                 <a:solidFill>
                   <a:srgbClr val="F4F8FC"/>
                 </a:solidFill>
@@ -19780,7 +19780,7 @@
               </a:spcAft>
             </a:pPr>
             <a:r>
-              <a:rPr sz="1050" b="1">
+              <a:rPr sz="1200" b="1">
                 <a:solidFill>
                   <a:srgbClr val="F4F8FC"/>
                 </a:solidFill>
@@ -19794,7 +19794,7 @@
       </p:sp>
       <p:sp>
         <p:nvSpPr>
-          <p:cNvPr id="19" name="technology-group-"/>
+          <p:cNvPr id="19" name="technology-group-knowledge-search"/>
           <p:cNvSpPr txBox="1"/>
           <p:nvPr/>
         </p:nvSpPr>
@@ -19894,7 +19894,7 @@
               </a:spcAft>
             </a:pPr>
             <a:r>
-              <a:rPr sz="1300" b="1">
+              <a:rPr sz="1200" b="1">
                 <a:solidFill>
                   <a:srgbClr val="F4F8FC"/>
                 </a:solidFill>
@@ -19963,7 +19963,7 @@
               </a:spcAft>
             </a:pPr>
             <a:r>
-              <a:rPr sz="1300" b="1">
+              <a:rPr sz="1200" b="1">
                 <a:solidFill>
                   <a:srgbClr val="F4F8FC"/>
                 </a:solidFill>
@@ -20032,7 +20032,7 @@
               </a:spcAft>
             </a:pPr>
             <a:r>
-              <a:rPr sz="1300" b="1">
+              <a:rPr sz="1200" b="1">
                 <a:solidFill>
                   <a:srgbClr val="F4F8FC"/>
                 </a:solidFill>
@@ -20046,7 +20046,7 @@
       </p:sp>
       <p:sp>
         <p:nvSpPr>
-          <p:cNvPr id="23" name="technology-group-"/>
+          <p:cNvPr id="23" name="technology-group-engineering-tools"/>
           <p:cNvSpPr txBox="1"/>
           <p:nvPr/>
         </p:nvSpPr>
@@ -20146,7 +20146,7 @@
               </a:spcAft>
             </a:pPr>
             <a:r>
-              <a:rPr sz="1300" b="1">
+              <a:rPr sz="1200" b="1">
                 <a:solidFill>
                   <a:srgbClr val="F4F8FC"/>
                 </a:solidFill>
@@ -20215,7 +20215,7 @@
               </a:spcAft>
             </a:pPr>
             <a:r>
-              <a:rPr sz="1300" b="1">
+              <a:rPr sz="1200" b="1">
                 <a:solidFill>
                   <a:srgbClr val="F4F8FC"/>
                 </a:solidFill>
@@ -20284,7 +20284,7 @@
               </a:spcAft>
             </a:pPr>
             <a:r>
-              <a:rPr sz="1300" b="1">
+              <a:rPr sz="1200" b="1">
                 <a:solidFill>
                   <a:srgbClr val="F4F8FC"/>
                 </a:solidFill>

</xml_diff>